<commit_message>
all-slides-with-answers.pdf all-slides.pdf hierarchies.pdf hierarchies.pptx
</commit_message>
<xml_diff>
--- a/ipsa/slides/hierarchies.pptx
+++ b/ipsa/slides/hierarchies.pptx
@@ -135,12 +135,20 @@
 </p:presentation>
 </file>
 
+<file path=ppt/revisionInfo.xml><?xml version="1.0" encoding="utf-8"?>
+<p1510:revInfo xmlns:a="http://schemas.openxmlformats.org/drawingml/2006/main" xmlns:r="http://schemas.openxmlformats.org/officeDocument/2006/relationships" xmlns:p1510="http://schemas.microsoft.com/office/powerpoint/2015/10/main">
+  <p1510:revLst>
+    <p1510:client id="{DF42FA1A-F726-4471-A8FF-CB6ED2969EB7}" v="58" dt="2026-03-04T06:17:17.763"/>
+  </p1510:revLst>
+</p1510:revInfo>
+</file>
+
 <file path=ppt/changesInfos/changesInfo1.xml><?xml version="1.0" encoding="utf-8"?>
 <pc:chgInfo xmlns:a="http://schemas.openxmlformats.org/drawingml/2006/main" xmlns:r="http://schemas.openxmlformats.org/officeDocument/2006/relationships" xmlns:ac="http://schemas.microsoft.com/office/drawing/2013/main/command" xmlns:pc="http://schemas.microsoft.com/office/powerpoint/2013/main/command">
   <pc:docChgLst>
     <pc:chgData name="Gerth Stølting Brodal" userId="04ef4784-6591-4f86-a140-f5c3b108582a" providerId="ADAL" clId="{73BAC7D6-516A-44B5-B4B0-C7B08CA8B392}"/>
-    <pc:docChg chg="modSld">
-      <pc:chgData name="Gerth Stølting Brodal" userId="04ef4784-6591-4f86-a140-f5c3b108582a" providerId="ADAL" clId="{73BAC7D6-516A-44B5-B4B0-C7B08CA8B392}" dt="2026-03-02T12:09:20.499" v="0" actId="790"/>
+    <pc:docChg chg="undo custSel modSld">
+      <pc:chgData name="Gerth Stølting Brodal" userId="04ef4784-6591-4f86-a140-f5c3b108582a" providerId="ADAL" clId="{73BAC7D6-516A-44B5-B4B0-C7B08CA8B392}" dt="2026-03-04T06:19:44.158" v="1290" actId="313"/>
       <pc:docMkLst>
         <pc:docMk/>
       </pc:docMkLst>
@@ -168,7 +176,7 @@
         </pc:spChg>
       </pc:sldChg>
       <pc:sldChg chg="modSp mod">
-        <pc:chgData name="Gerth Stølting Brodal" userId="04ef4784-6591-4f86-a140-f5c3b108582a" providerId="ADAL" clId="{73BAC7D6-516A-44B5-B4B0-C7B08CA8B392}" dt="2026-03-02T12:09:20.499" v="0" actId="790"/>
+        <pc:chgData name="Gerth Stølting Brodal" userId="04ef4784-6591-4f86-a140-f5c3b108582a" providerId="ADAL" clId="{73BAC7D6-516A-44B5-B4B0-C7B08CA8B392}" dt="2026-03-04T06:07:46.768" v="1035" actId="14100"/>
         <pc:sldMkLst>
           <pc:docMk/>
           <pc:sldMk cId="3312054074" sldId="621"/>
@@ -182,7 +190,7 @@
           </ac:spMkLst>
         </pc:spChg>
         <pc:spChg chg="mod">
-          <ac:chgData name="Gerth Stølting Brodal" userId="04ef4784-6591-4f86-a140-f5c3b108582a" providerId="ADAL" clId="{73BAC7D6-516A-44B5-B4B0-C7B08CA8B392}" dt="2026-03-02T12:09:20.499" v="0" actId="790"/>
+          <ac:chgData name="Gerth Stølting Brodal" userId="04ef4784-6591-4f86-a140-f5c3b108582a" providerId="ADAL" clId="{73BAC7D6-516A-44B5-B4B0-C7B08CA8B392}" dt="2026-03-04T06:07:46.768" v="1035" actId="14100"/>
           <ac:spMkLst>
             <pc:docMk/>
             <pc:sldMk cId="3312054074" sldId="621"/>
@@ -190,8 +198,8 @@
           </ac:spMkLst>
         </pc:spChg>
       </pc:sldChg>
-      <pc:sldChg chg="modSp mod">
-        <pc:chgData name="Gerth Stølting Brodal" userId="04ef4784-6591-4f86-a140-f5c3b108582a" providerId="ADAL" clId="{73BAC7D6-516A-44B5-B4B0-C7B08CA8B392}" dt="2026-03-02T12:09:20.499" v="0" actId="790"/>
+      <pc:sldChg chg="modSp mod modNotesTx">
+        <pc:chgData name="Gerth Stølting Brodal" userId="04ef4784-6591-4f86-a140-f5c3b108582a" providerId="ADAL" clId="{73BAC7D6-516A-44B5-B4B0-C7B08CA8B392}" dt="2026-03-04T04:43:51.307" v="120" actId="20577"/>
         <pc:sldMkLst>
           <pc:docMk/>
           <pc:sldMk cId="2915881254" sldId="676"/>
@@ -205,7 +213,7 @@
           </ac:spMkLst>
         </pc:spChg>
         <pc:spChg chg="mod">
-          <ac:chgData name="Gerth Stølting Brodal" userId="04ef4784-6591-4f86-a140-f5c3b108582a" providerId="ADAL" clId="{73BAC7D6-516A-44B5-B4B0-C7B08CA8B392}" dt="2026-03-02T12:09:20.499" v="0" actId="790"/>
+          <ac:chgData name="Gerth Stølting Brodal" userId="04ef4784-6591-4f86-a140-f5c3b108582a" providerId="ADAL" clId="{73BAC7D6-516A-44B5-B4B0-C7B08CA8B392}" dt="2026-03-04T04:43:13.535" v="88" actId="14100"/>
           <ac:spMkLst>
             <pc:docMk/>
             <pc:sldMk cId="2915881254" sldId="676"/>
@@ -222,7 +230,7 @@
         </pc:graphicFrameChg>
       </pc:sldChg>
       <pc:sldChg chg="modSp mod">
-        <pc:chgData name="Gerth Stølting Brodal" userId="04ef4784-6591-4f86-a140-f5c3b108582a" providerId="ADAL" clId="{73BAC7D6-516A-44B5-B4B0-C7B08CA8B392}" dt="2026-03-02T12:09:20.499" v="0" actId="790"/>
+        <pc:chgData name="Gerth Stølting Brodal" userId="04ef4784-6591-4f86-a140-f5c3b108582a" providerId="ADAL" clId="{73BAC7D6-516A-44B5-B4B0-C7B08CA8B392}" dt="2026-03-04T05:49:56.527" v="966"/>
         <pc:sldMkLst>
           <pc:docMk/>
           <pc:sldMk cId="2256920451" sldId="677"/>
@@ -236,7 +244,7 @@
           </ac:spMkLst>
         </pc:spChg>
         <pc:spChg chg="mod">
-          <ac:chgData name="Gerth Stølting Brodal" userId="04ef4784-6591-4f86-a140-f5c3b108582a" providerId="ADAL" clId="{73BAC7D6-516A-44B5-B4B0-C7B08CA8B392}" dt="2026-03-02T12:09:20.499" v="0" actId="790"/>
+          <ac:chgData name="Gerth Stølting Brodal" userId="04ef4784-6591-4f86-a140-f5c3b108582a" providerId="ADAL" clId="{73BAC7D6-516A-44B5-B4B0-C7B08CA8B392}" dt="2026-03-04T05:49:56.527" v="966"/>
           <ac:spMkLst>
             <pc:docMk/>
             <pc:sldMk cId="2256920451" sldId="677"/>
@@ -292,13 +300,13 @@
         </pc:spChg>
       </pc:sldChg>
       <pc:sldChg chg="modSp mod">
-        <pc:chgData name="Gerth Stølting Brodal" userId="04ef4784-6591-4f86-a140-f5c3b108582a" providerId="ADAL" clId="{73BAC7D6-516A-44B5-B4B0-C7B08CA8B392}" dt="2026-03-02T12:09:20.499" v="0" actId="790"/>
+        <pc:chgData name="Gerth Stølting Brodal" userId="04ef4784-6591-4f86-a140-f5c3b108582a" providerId="ADAL" clId="{73BAC7D6-516A-44B5-B4B0-C7B08CA8B392}" dt="2026-03-04T05:38:03.724" v="922" actId="20577"/>
         <pc:sldMkLst>
           <pc:docMk/>
           <pc:sldMk cId="472647731" sldId="686"/>
         </pc:sldMkLst>
         <pc:spChg chg="mod">
-          <ac:chgData name="Gerth Stølting Brodal" userId="04ef4784-6591-4f86-a140-f5c3b108582a" providerId="ADAL" clId="{73BAC7D6-516A-44B5-B4B0-C7B08CA8B392}" dt="2026-03-02T12:09:20.499" v="0" actId="790"/>
+          <ac:chgData name="Gerth Stølting Brodal" userId="04ef4784-6591-4f86-a140-f5c3b108582a" providerId="ADAL" clId="{73BAC7D6-516A-44B5-B4B0-C7B08CA8B392}" dt="2026-03-04T05:38:03.724" v="922" actId="20577"/>
           <ac:spMkLst>
             <pc:docMk/>
             <pc:sldMk cId="472647731" sldId="686"/>
@@ -354,7 +362,7 @@
           </ac:graphicFrameMkLst>
         </pc:graphicFrameChg>
         <pc:graphicFrameChg chg="modGraphic">
-          <ac:chgData name="Gerth Stølting Brodal" userId="04ef4784-6591-4f86-a140-f5c3b108582a" providerId="ADAL" clId="{73BAC7D6-516A-44B5-B4B0-C7B08CA8B392}" dt="2026-03-02T12:09:20.499" v="0" actId="790"/>
+          <ac:chgData name="Gerth Stølting Brodal" userId="04ef4784-6591-4f86-a140-f5c3b108582a" providerId="ADAL" clId="{73BAC7D6-516A-44B5-B4B0-C7B08CA8B392}" dt="2026-03-04T04:48:27.957" v="121" actId="20577"/>
           <ac:graphicFrameMkLst>
             <pc:docMk/>
             <pc:sldMk cId="472647731" sldId="686"/>
@@ -379,13 +387,13 @@
         </pc:graphicFrameChg>
       </pc:sldChg>
       <pc:sldChg chg="modSp mod">
-        <pc:chgData name="Gerth Stølting Brodal" userId="04ef4784-6591-4f86-a140-f5c3b108582a" providerId="ADAL" clId="{73BAC7D6-516A-44B5-B4B0-C7B08CA8B392}" dt="2026-03-02T12:09:20.499" v="0" actId="790"/>
+        <pc:chgData name="Gerth Stølting Brodal" userId="04ef4784-6591-4f86-a140-f5c3b108582a" providerId="ADAL" clId="{73BAC7D6-516A-44B5-B4B0-C7B08CA8B392}" dt="2026-03-04T05:38:09.714" v="924" actId="20577"/>
         <pc:sldMkLst>
           <pc:docMk/>
           <pc:sldMk cId="4198244594" sldId="687"/>
         </pc:sldMkLst>
         <pc:spChg chg="mod">
-          <ac:chgData name="Gerth Stølting Brodal" userId="04ef4784-6591-4f86-a140-f5c3b108582a" providerId="ADAL" clId="{73BAC7D6-516A-44B5-B4B0-C7B08CA8B392}" dt="2026-03-02T12:09:20.499" v="0" actId="790"/>
+          <ac:chgData name="Gerth Stølting Brodal" userId="04ef4784-6591-4f86-a140-f5c3b108582a" providerId="ADAL" clId="{73BAC7D6-516A-44B5-B4B0-C7B08CA8B392}" dt="2026-03-04T05:38:09.714" v="924" actId="20577"/>
           <ac:spMkLst>
             <pc:docMk/>
             <pc:sldMk cId="4198244594" sldId="687"/>
@@ -591,8 +599,8 @@
           </ac:graphicFrameMkLst>
         </pc:graphicFrameChg>
       </pc:sldChg>
-      <pc:sldChg chg="modSp mod">
-        <pc:chgData name="Gerth Stølting Brodal" userId="04ef4784-6591-4f86-a140-f5c3b108582a" providerId="ADAL" clId="{73BAC7D6-516A-44B5-B4B0-C7B08CA8B392}" dt="2026-03-02T12:09:20.499" v="0" actId="790"/>
+      <pc:sldChg chg="modSp mod modNotesTx">
+        <pc:chgData name="Gerth Stølting Brodal" userId="04ef4784-6591-4f86-a140-f5c3b108582a" providerId="ADAL" clId="{73BAC7D6-516A-44B5-B4B0-C7B08CA8B392}" dt="2026-03-04T05:15:32.581" v="395" actId="20577"/>
         <pc:sldMkLst>
           <pc:docMk/>
           <pc:sldMk cId="4066017642" sldId="690"/>
@@ -670,14 +678,14 @@
           </ac:graphicFrameMkLst>
         </pc:graphicFrameChg>
       </pc:sldChg>
-      <pc:sldChg chg="modSp mod">
-        <pc:chgData name="Gerth Stølting Brodal" userId="04ef4784-6591-4f86-a140-f5c3b108582a" providerId="ADAL" clId="{73BAC7D6-516A-44B5-B4B0-C7B08CA8B392}" dt="2026-03-02T12:09:20.499" v="0" actId="790"/>
+      <pc:sldChg chg="addSp modSp mod addAnim delAnim modAnim modNotesTx">
+        <pc:chgData name="Gerth Stølting Brodal" userId="04ef4784-6591-4f86-a140-f5c3b108582a" providerId="ADAL" clId="{73BAC7D6-516A-44B5-B4B0-C7B08CA8B392}" dt="2026-03-04T05:33:50.685" v="920" actId="1076"/>
         <pc:sldMkLst>
           <pc:docMk/>
           <pc:sldMk cId="1968748728" sldId="691"/>
         </pc:sldMkLst>
         <pc:spChg chg="mod">
-          <ac:chgData name="Gerth Stølting Brodal" userId="04ef4784-6591-4f86-a140-f5c3b108582a" providerId="ADAL" clId="{73BAC7D6-516A-44B5-B4B0-C7B08CA8B392}" dt="2026-03-02T12:09:20.499" v="0" actId="790"/>
+          <ac:chgData name="Gerth Stølting Brodal" userId="04ef4784-6591-4f86-a140-f5c3b108582a" providerId="ADAL" clId="{73BAC7D6-516A-44B5-B4B0-C7B08CA8B392}" dt="2026-03-04T05:26:20.007" v="621" actId="1076"/>
           <ac:spMkLst>
             <pc:docMk/>
             <pc:sldMk cId="1968748728" sldId="691"/>
@@ -685,7 +693,23 @@
           </ac:spMkLst>
         </pc:spChg>
         <pc:spChg chg="mod">
-          <ac:chgData name="Gerth Stølting Brodal" userId="04ef4784-6591-4f86-a140-f5c3b108582a" providerId="ADAL" clId="{73BAC7D6-516A-44B5-B4B0-C7B08CA8B392}" dt="2026-03-02T12:09:20.499" v="0" actId="790"/>
+          <ac:chgData name="Gerth Stølting Brodal" userId="04ef4784-6591-4f86-a140-f5c3b108582a" providerId="ADAL" clId="{73BAC7D6-516A-44B5-B4B0-C7B08CA8B392}" dt="2026-03-04T05:24:24.448" v="608"/>
+          <ac:spMkLst>
+            <pc:docMk/>
+            <pc:sldMk cId="1968748728" sldId="691"/>
+            <ac:spMk id="8" creationId="{DA4AFD94-8B08-B55A-419D-D8C75E590CDE}"/>
+          </ac:spMkLst>
+        </pc:spChg>
+        <pc:spChg chg="add mod">
+          <ac:chgData name="Gerth Stølting Brodal" userId="04ef4784-6591-4f86-a140-f5c3b108582a" providerId="ADAL" clId="{73BAC7D6-516A-44B5-B4B0-C7B08CA8B392}" dt="2026-03-04T05:33:31.376" v="919" actId="1076"/>
+          <ac:spMkLst>
+            <pc:docMk/>
+            <pc:sldMk cId="1968748728" sldId="691"/>
+            <ac:spMk id="11" creationId="{804BC34C-4FCC-19E1-6472-038F072B226F}"/>
+          </ac:spMkLst>
+        </pc:spChg>
+        <pc:spChg chg="mod">
+          <ac:chgData name="Gerth Stølting Brodal" userId="04ef4784-6591-4f86-a140-f5c3b108582a" providerId="ADAL" clId="{73BAC7D6-516A-44B5-B4B0-C7B08CA8B392}" dt="2026-03-04T05:33:50.685" v="920" actId="1076"/>
           <ac:spMkLst>
             <pc:docMk/>
             <pc:sldMk cId="1968748728" sldId="691"/>
@@ -693,40 +717,88 @@
           </ac:spMkLst>
         </pc:spChg>
         <pc:spChg chg="mod">
-          <ac:chgData name="Gerth Stølting Brodal" userId="04ef4784-6591-4f86-a140-f5c3b108582a" providerId="ADAL" clId="{73BAC7D6-516A-44B5-B4B0-C7B08CA8B392}" dt="2026-03-02T12:09:20.499" v="0" actId="790"/>
+          <ac:chgData name="Gerth Stølting Brodal" userId="04ef4784-6591-4f86-a140-f5c3b108582a" providerId="ADAL" clId="{73BAC7D6-516A-44B5-B4B0-C7B08CA8B392}" dt="2026-03-04T05:24:23.729" v="607" actId="164"/>
           <ac:spMkLst>
             <pc:docMk/>
             <pc:sldMk cId="1968748728" sldId="691"/>
             <ac:spMk id="18" creationId="{00000000-0000-0000-0000-000000000000}"/>
           </ac:spMkLst>
         </pc:spChg>
-        <pc:graphicFrameChg chg="modGraphic">
-          <ac:chgData name="Gerth Stølting Brodal" userId="04ef4784-6591-4f86-a140-f5c3b108582a" providerId="ADAL" clId="{73BAC7D6-516A-44B5-B4B0-C7B08CA8B392}" dt="2026-03-02T12:09:20.499" v="0" actId="790"/>
+        <pc:grpChg chg="add mod">
+          <ac:chgData name="Gerth Stølting Brodal" userId="04ef4784-6591-4f86-a140-f5c3b108582a" providerId="ADAL" clId="{73BAC7D6-516A-44B5-B4B0-C7B08CA8B392}" dt="2026-03-04T05:26:02.748" v="619" actId="1076"/>
+          <ac:grpSpMkLst>
+            <pc:docMk/>
+            <pc:sldMk cId="1968748728" sldId="691"/>
+            <ac:grpSpMk id="5" creationId="{B0BED0AA-C56D-CCF2-371A-7324313BBF6B}"/>
+          </ac:grpSpMkLst>
+        </pc:grpChg>
+        <pc:grpChg chg="add mod">
+          <ac:chgData name="Gerth Stølting Brodal" userId="04ef4784-6591-4f86-a140-f5c3b108582a" providerId="ADAL" clId="{73BAC7D6-516A-44B5-B4B0-C7B08CA8B392}" dt="2026-03-04T05:27:10.268" v="624" actId="1035"/>
+          <ac:grpSpMkLst>
+            <pc:docMk/>
+            <pc:sldMk cId="1968748728" sldId="691"/>
+            <ac:grpSpMk id="6" creationId="{7208FCC4-64A7-653E-95CB-130ECB7B2479}"/>
+          </ac:grpSpMkLst>
+        </pc:grpChg>
+        <pc:graphicFrameChg chg="add mod modGraphic">
+          <ac:chgData name="Gerth Stølting Brodal" userId="04ef4784-6591-4f86-a140-f5c3b108582a" providerId="ADAL" clId="{73BAC7D6-516A-44B5-B4B0-C7B08CA8B392}" dt="2026-03-04T05:27:10.268" v="624" actId="1035"/>
+          <ac:graphicFrameMkLst>
+            <pc:docMk/>
+            <pc:sldMk cId="1968748728" sldId="691"/>
+            <ac:graphicFrameMk id="3" creationId="{9A506DDC-96F9-7D50-744A-D7293098E33E}"/>
+          </ac:graphicFrameMkLst>
+        </pc:graphicFrameChg>
+        <pc:graphicFrameChg chg="mod modGraphic">
+          <ac:chgData name="Gerth Stølting Brodal" userId="04ef4784-6591-4f86-a140-f5c3b108582a" providerId="ADAL" clId="{73BAC7D6-516A-44B5-B4B0-C7B08CA8B392}" dt="2026-03-04T05:26:02.748" v="619" actId="1076"/>
           <ac:graphicFrameMkLst>
             <pc:docMk/>
             <pc:sldMk cId="1968748728" sldId="691"/>
             <ac:graphicFrameMk id="4" creationId="{00000000-0000-0000-0000-000000000000}"/>
           </ac:graphicFrameMkLst>
         </pc:graphicFrameChg>
-        <pc:graphicFrameChg chg="modGraphic">
-          <ac:chgData name="Gerth Stølting Brodal" userId="04ef4784-6591-4f86-a140-f5c3b108582a" providerId="ADAL" clId="{73BAC7D6-516A-44B5-B4B0-C7B08CA8B392}" dt="2026-03-02T12:09:20.499" v="0" actId="790"/>
+        <pc:graphicFrameChg chg="mod modGraphic">
+          <ac:chgData name="Gerth Stølting Brodal" userId="04ef4784-6591-4f86-a140-f5c3b108582a" providerId="ADAL" clId="{73BAC7D6-516A-44B5-B4B0-C7B08CA8B392}" dt="2026-03-04T05:26:12.566" v="620" actId="1076"/>
           <ac:graphicFrameMkLst>
             <pc:docMk/>
             <pc:sldMk cId="1968748728" sldId="691"/>
             <ac:graphicFrameMk id="10" creationId="{00000000-0000-0000-0000-000000000000}"/>
           </ac:graphicFrameMkLst>
         </pc:graphicFrameChg>
-        <pc:graphicFrameChg chg="modGraphic">
-          <ac:chgData name="Gerth Stølting Brodal" userId="04ef4784-6591-4f86-a140-f5c3b108582a" providerId="ADAL" clId="{73BAC7D6-516A-44B5-B4B0-C7B08CA8B392}" dt="2026-03-02T12:09:20.499" v="0" actId="790"/>
+        <pc:graphicFrameChg chg="mod modGraphic">
+          <ac:chgData name="Gerth Stølting Brodal" userId="04ef4784-6591-4f86-a140-f5c3b108582a" providerId="ADAL" clId="{73BAC7D6-516A-44B5-B4B0-C7B08CA8B392}" dt="2026-03-04T05:26:02.748" v="619" actId="1076"/>
           <ac:graphicFrameMkLst>
             <pc:docMk/>
             <pc:sldMk cId="1968748728" sldId="691"/>
             <ac:graphicFrameMk id="13" creationId="{00000000-0000-0000-0000-000000000000}"/>
           </ac:graphicFrameMkLst>
         </pc:graphicFrameChg>
+        <pc:cxnChg chg="mod">
+          <ac:chgData name="Gerth Stølting Brodal" userId="04ef4784-6591-4f86-a140-f5c3b108582a" providerId="ADAL" clId="{73BAC7D6-516A-44B5-B4B0-C7B08CA8B392}" dt="2026-03-04T05:24:24.448" v="608"/>
+          <ac:cxnSpMkLst>
+            <pc:docMk/>
+            <pc:sldMk cId="1968748728" sldId="691"/>
+            <ac:cxnSpMk id="7" creationId="{4315005B-87B9-D512-BAA1-38EDCFF65119}"/>
+          </ac:cxnSpMkLst>
+        </pc:cxnChg>
+        <pc:cxnChg chg="mod">
+          <ac:chgData name="Gerth Stølting Brodal" userId="04ef4784-6591-4f86-a140-f5c3b108582a" providerId="ADAL" clId="{73BAC7D6-516A-44B5-B4B0-C7B08CA8B392}" dt="2026-03-04T05:25:53.258" v="618" actId="1076"/>
+          <ac:cxnSpMkLst>
+            <pc:docMk/>
+            <pc:sldMk cId="1968748728" sldId="691"/>
+            <ac:cxnSpMk id="14" creationId="{00000000-0000-0000-0000-000000000000}"/>
+          </ac:cxnSpMkLst>
+        </pc:cxnChg>
+        <pc:cxnChg chg="mod">
+          <ac:chgData name="Gerth Stølting Brodal" userId="04ef4784-6591-4f86-a140-f5c3b108582a" providerId="ADAL" clId="{73BAC7D6-516A-44B5-B4B0-C7B08CA8B392}" dt="2026-03-04T05:24:23.729" v="607" actId="164"/>
+          <ac:cxnSpMkLst>
+            <pc:docMk/>
+            <pc:sldMk cId="1968748728" sldId="691"/>
+            <ac:cxnSpMk id="16" creationId="{00000000-0000-0000-0000-000000000000}"/>
+          </ac:cxnSpMkLst>
+        </pc:cxnChg>
       </pc:sldChg>
       <pc:sldChg chg="modSp mod">
-        <pc:chgData name="Gerth Stølting Brodal" userId="04ef4784-6591-4f86-a140-f5c3b108582a" providerId="ADAL" clId="{73BAC7D6-516A-44B5-B4B0-C7B08CA8B392}" dt="2026-03-02T12:09:20.499" v="0" actId="790"/>
+        <pc:chgData name="Gerth Stølting Brodal" userId="04ef4784-6591-4f86-a140-f5c3b108582a" providerId="ADAL" clId="{73BAC7D6-516A-44B5-B4B0-C7B08CA8B392}" dt="2026-03-04T05:41:23.819" v="938" actId="207"/>
         <pc:sldMkLst>
           <pc:docMk/>
           <pc:sldMk cId="3232688819" sldId="692"/>
@@ -755,8 +827,8 @@
             <ac:spMk id="5" creationId="{00000000-0000-0000-0000-000000000000}"/>
           </ac:spMkLst>
         </pc:spChg>
-        <pc:graphicFrameChg chg="modGraphic">
-          <ac:chgData name="Gerth Stølting Brodal" userId="04ef4784-6591-4f86-a140-f5c3b108582a" providerId="ADAL" clId="{73BAC7D6-516A-44B5-B4B0-C7B08CA8B392}" dt="2026-03-02T12:09:20.499" v="0" actId="790"/>
+        <pc:graphicFrameChg chg="mod modGraphic">
+          <ac:chgData name="Gerth Stølting Brodal" userId="04ef4784-6591-4f86-a140-f5c3b108582a" providerId="ADAL" clId="{73BAC7D6-516A-44B5-B4B0-C7B08CA8B392}" dt="2026-03-04T05:41:23.819" v="938" actId="207"/>
           <ac:graphicFrameMkLst>
             <pc:docMk/>
             <pc:sldMk cId="3232688819" sldId="692"/>
@@ -765,7 +837,7 @@
         </pc:graphicFrameChg>
       </pc:sldChg>
       <pc:sldChg chg="modSp mod">
-        <pc:chgData name="Gerth Stølting Brodal" userId="04ef4784-6591-4f86-a140-f5c3b108582a" providerId="ADAL" clId="{73BAC7D6-516A-44B5-B4B0-C7B08CA8B392}" dt="2026-03-02T12:09:20.499" v="0" actId="790"/>
+        <pc:chgData name="Gerth Stølting Brodal" userId="04ef4784-6591-4f86-a140-f5c3b108582a" providerId="ADAL" clId="{73BAC7D6-516A-44B5-B4B0-C7B08CA8B392}" dt="2026-03-04T05:51:03.893" v="982" actId="313"/>
         <pc:sldMkLst>
           <pc:docMk/>
           <pc:sldMk cId="3111229943" sldId="693"/>
@@ -786,8 +858,8 @@
             <ac:spMk id="6" creationId="{00000000-0000-0000-0000-000000000000}"/>
           </ac:spMkLst>
         </pc:spChg>
-        <pc:graphicFrameChg chg="modGraphic">
-          <ac:chgData name="Gerth Stølting Brodal" userId="04ef4784-6591-4f86-a140-f5c3b108582a" providerId="ADAL" clId="{73BAC7D6-516A-44B5-B4B0-C7B08CA8B392}" dt="2026-03-02T12:09:20.499" v="0" actId="790"/>
+        <pc:graphicFrameChg chg="mod modGraphic">
+          <ac:chgData name="Gerth Stølting Brodal" userId="04ef4784-6591-4f86-a140-f5c3b108582a" providerId="ADAL" clId="{73BAC7D6-516A-44B5-B4B0-C7B08CA8B392}" dt="2026-03-04T05:51:03.893" v="982" actId="313"/>
           <ac:graphicFrameMkLst>
             <pc:docMk/>
             <pc:sldMk cId="3111229943" sldId="693"/>
@@ -843,7 +915,7 @@
         </pc:graphicFrameChg>
       </pc:sldChg>
       <pc:sldChg chg="modSp mod">
-        <pc:chgData name="Gerth Stølting Brodal" userId="04ef4784-6591-4f86-a140-f5c3b108582a" providerId="ADAL" clId="{73BAC7D6-516A-44B5-B4B0-C7B08CA8B392}" dt="2026-03-02T12:09:20.499" v="0" actId="790"/>
+        <pc:chgData name="Gerth Stølting Brodal" userId="04ef4784-6591-4f86-a140-f5c3b108582a" providerId="ADAL" clId="{73BAC7D6-516A-44B5-B4B0-C7B08CA8B392}" dt="2026-03-04T05:49:56.527" v="966"/>
         <pc:sldMkLst>
           <pc:docMk/>
           <pc:sldMk cId="2881013406" sldId="695"/>
@@ -857,7 +929,7 @@
           </ac:spMkLst>
         </pc:spChg>
         <pc:spChg chg="mod">
-          <ac:chgData name="Gerth Stølting Brodal" userId="04ef4784-6591-4f86-a140-f5c3b108582a" providerId="ADAL" clId="{73BAC7D6-516A-44B5-B4B0-C7B08CA8B392}" dt="2026-03-02T12:09:20.499" v="0" actId="790"/>
+          <ac:chgData name="Gerth Stølting Brodal" userId="04ef4784-6591-4f86-a140-f5c3b108582a" providerId="ADAL" clId="{73BAC7D6-516A-44B5-B4B0-C7B08CA8B392}" dt="2026-03-04T05:49:56.527" v="966"/>
           <ac:spMkLst>
             <pc:docMk/>
             <pc:sldMk cId="2881013406" sldId="695"/>
@@ -881,7 +953,7 @@
           </ac:spMkLst>
         </pc:spChg>
         <pc:graphicFrameChg chg="modGraphic">
-          <ac:chgData name="Gerth Stølting Brodal" userId="04ef4784-6591-4f86-a140-f5c3b108582a" providerId="ADAL" clId="{73BAC7D6-516A-44B5-B4B0-C7B08CA8B392}" dt="2026-03-02T12:09:20.499" v="0" actId="790"/>
+          <ac:chgData name="Gerth Stølting Brodal" userId="04ef4784-6591-4f86-a140-f5c3b108582a" providerId="ADAL" clId="{73BAC7D6-516A-44B5-B4B0-C7B08CA8B392}" dt="2026-03-04T05:49:40.748" v="956" actId="313"/>
           <ac:graphicFrameMkLst>
             <pc:docMk/>
             <pc:sldMk cId="2881013406" sldId="695"/>
@@ -889,14 +961,14 @@
           </ac:graphicFrameMkLst>
         </pc:graphicFrameChg>
       </pc:sldChg>
-      <pc:sldChg chg="modSp mod">
-        <pc:chgData name="Gerth Stølting Brodal" userId="04ef4784-6591-4f86-a140-f5c3b108582a" providerId="ADAL" clId="{73BAC7D6-516A-44B5-B4B0-C7B08CA8B392}" dt="2026-03-02T12:09:20.499" v="0" actId="790"/>
+      <pc:sldChg chg="addSp modSp mod modAnim">
+        <pc:chgData name="Gerth Stølting Brodal" userId="04ef4784-6591-4f86-a140-f5c3b108582a" providerId="ADAL" clId="{73BAC7D6-516A-44B5-B4B0-C7B08CA8B392}" dt="2026-03-04T05:59:24.821" v="1010" actId="1076"/>
         <pc:sldMkLst>
           <pc:docMk/>
           <pc:sldMk cId="1983749371" sldId="696"/>
         </pc:sldMkLst>
         <pc:spChg chg="mod">
-          <ac:chgData name="Gerth Stølting Brodal" userId="04ef4784-6591-4f86-a140-f5c3b108582a" providerId="ADAL" clId="{73BAC7D6-516A-44B5-B4B0-C7B08CA8B392}" dt="2026-03-02T12:09:20.499" v="0" actId="790"/>
+          <ac:chgData name="Gerth Stølting Brodal" userId="04ef4784-6591-4f86-a140-f5c3b108582a" providerId="ADAL" clId="{73BAC7D6-516A-44B5-B4B0-C7B08CA8B392}" dt="2026-03-04T05:59:24.821" v="1010" actId="1076"/>
           <ac:spMkLst>
             <pc:docMk/>
             <pc:sldMk cId="1983749371" sldId="696"/>
@@ -920,19 +992,27 @@
           </ac:spMkLst>
         </pc:spChg>
         <pc:spChg chg="mod">
-          <ac:chgData name="Gerth Stølting Brodal" userId="04ef4784-6591-4f86-a140-f5c3b108582a" providerId="ADAL" clId="{73BAC7D6-516A-44B5-B4B0-C7B08CA8B392}" dt="2026-03-02T12:09:20.499" v="0" actId="790"/>
+          <ac:chgData name="Gerth Stølting Brodal" userId="04ef4784-6591-4f86-a140-f5c3b108582a" providerId="ADAL" clId="{73BAC7D6-516A-44B5-B4B0-C7B08CA8B392}" dt="2026-03-04T05:58:45.259" v="1002" actId="313"/>
           <ac:spMkLst>
             <pc:docMk/>
             <pc:sldMk cId="1983749371" sldId="696"/>
             <ac:spMk id="6" creationId="{FEE6BC6B-68CC-437E-BFBA-9B24D826FAF6}"/>
           </ac:spMkLst>
         </pc:spChg>
-        <pc:graphicFrameChg chg="modGraphic">
-          <ac:chgData name="Gerth Stølting Brodal" userId="04ef4784-6591-4f86-a140-f5c3b108582a" providerId="ADAL" clId="{73BAC7D6-516A-44B5-B4B0-C7B08CA8B392}" dt="2026-03-02T12:09:20.499" v="0" actId="790"/>
+        <pc:graphicFrameChg chg="mod modGraphic">
+          <ac:chgData name="Gerth Stølting Brodal" userId="04ef4784-6591-4f86-a140-f5c3b108582a" providerId="ADAL" clId="{73BAC7D6-516A-44B5-B4B0-C7B08CA8B392}" dt="2026-03-04T05:59:17.142" v="1009" actId="1076"/>
           <ac:graphicFrameMkLst>
             <pc:docMk/>
             <pc:sldMk cId="1983749371" sldId="696"/>
             <ac:graphicFrameMk id="4" creationId="{00000000-0000-0000-0000-000000000000}"/>
+          </ac:graphicFrameMkLst>
+        </pc:graphicFrameChg>
+        <pc:graphicFrameChg chg="add mod modGraphic">
+          <ac:chgData name="Gerth Stølting Brodal" userId="04ef4784-6591-4f86-a140-f5c3b108582a" providerId="ADAL" clId="{73BAC7D6-516A-44B5-B4B0-C7B08CA8B392}" dt="2026-03-04T05:57:40.324" v="996" actId="962"/>
+          <ac:graphicFrameMkLst>
+            <pc:docMk/>
+            <pc:sldMk cId="1983749371" sldId="696"/>
+            <ac:graphicFrameMk id="7" creationId="{A7E9FD67-C47B-0470-704B-29B86941CBB0}"/>
           </ac:graphicFrameMkLst>
         </pc:graphicFrameChg>
       </pc:sldChg>
@@ -967,8 +1047,8 @@
           </ac:graphicFrameMkLst>
         </pc:graphicFrameChg>
       </pc:sldChg>
-      <pc:sldChg chg="modSp mod">
-        <pc:chgData name="Gerth Stølting Brodal" userId="04ef4784-6591-4f86-a140-f5c3b108582a" providerId="ADAL" clId="{73BAC7D6-516A-44B5-B4B0-C7B08CA8B392}" dt="2026-03-02T12:09:20.499" v="0" actId="790"/>
+      <pc:sldChg chg="modSp mod modNotesTx">
+        <pc:chgData name="Gerth Stølting Brodal" userId="04ef4784-6591-4f86-a140-f5c3b108582a" providerId="ADAL" clId="{73BAC7D6-516A-44B5-B4B0-C7B08CA8B392}" dt="2026-03-04T06:04:52.901" v="1015" actId="2711"/>
         <pc:sldMkLst>
           <pc:docMk/>
           <pc:sldMk cId="776451279" sldId="698"/>
@@ -982,7 +1062,7 @@
           </ac:spMkLst>
         </pc:spChg>
         <pc:spChg chg="mod">
-          <ac:chgData name="Gerth Stølting Brodal" userId="04ef4784-6591-4f86-a140-f5c3b108582a" providerId="ADAL" clId="{73BAC7D6-516A-44B5-B4B0-C7B08CA8B392}" dt="2026-03-02T12:09:20.499" v="0" actId="790"/>
+          <ac:chgData name="Gerth Stølting Brodal" userId="04ef4784-6591-4f86-a140-f5c3b108582a" providerId="ADAL" clId="{73BAC7D6-516A-44B5-B4B0-C7B08CA8B392}" dt="2026-03-04T06:04:52.901" v="1015" actId="2711"/>
           <ac:spMkLst>
             <pc:docMk/>
             <pc:sldMk cId="776451279" sldId="698"/>
@@ -997,8 +1077,8 @@
             <ac:graphicFrameMk id="4" creationId="{00000000-0000-0000-0000-000000000000}"/>
           </ac:graphicFrameMkLst>
         </pc:graphicFrameChg>
-        <pc:graphicFrameChg chg="modGraphic">
-          <ac:chgData name="Gerth Stølting Brodal" userId="04ef4784-6591-4f86-a140-f5c3b108582a" providerId="ADAL" clId="{73BAC7D6-516A-44B5-B4B0-C7B08CA8B392}" dt="2026-03-02T12:09:20.499" v="0" actId="790"/>
+        <pc:graphicFrameChg chg="mod modGraphic">
+          <ac:chgData name="Gerth Stølting Brodal" userId="04ef4784-6591-4f86-a140-f5c3b108582a" providerId="ADAL" clId="{73BAC7D6-516A-44B5-B4B0-C7B08CA8B392}" dt="2026-03-04T05:51:10.342" v="983" actId="313"/>
           <ac:graphicFrameMkLst>
             <pc:docMk/>
             <pc:sldMk cId="776451279" sldId="698"/>
@@ -1006,8 +1086,8 @@
           </ac:graphicFrameMkLst>
         </pc:graphicFrameChg>
       </pc:sldChg>
-      <pc:sldChg chg="modSp mod">
-        <pc:chgData name="Gerth Stølting Brodal" userId="04ef4784-6591-4f86-a140-f5c3b108582a" providerId="ADAL" clId="{73BAC7D6-516A-44B5-B4B0-C7B08CA8B392}" dt="2026-03-02T12:09:20.499" v="0" actId="790"/>
+      <pc:sldChg chg="modSp mod modNotesTx">
+        <pc:chgData name="Gerth Stølting Brodal" userId="04ef4784-6591-4f86-a140-f5c3b108582a" providerId="ADAL" clId="{73BAC7D6-516A-44B5-B4B0-C7B08CA8B392}" dt="2026-03-04T06:19:44.158" v="1290" actId="313"/>
         <pc:sldMkLst>
           <pc:docMk/>
           <pc:sldMk cId="3840876851" sldId="699"/>
@@ -1028,8 +1108,8 @@
             <ac:spMk id="7" creationId="{00000000-0000-0000-0000-000000000000}"/>
           </ac:spMkLst>
         </pc:spChg>
-        <pc:graphicFrameChg chg="modGraphic">
-          <ac:chgData name="Gerth Stølting Brodal" userId="04ef4784-6591-4f86-a140-f5c3b108582a" providerId="ADAL" clId="{73BAC7D6-516A-44B5-B4B0-C7B08CA8B392}" dt="2026-03-02T12:09:20.499" v="0" actId="790"/>
+        <pc:graphicFrameChg chg="mod modGraphic">
+          <ac:chgData name="Gerth Stølting Brodal" userId="04ef4784-6591-4f86-a140-f5c3b108582a" providerId="ADAL" clId="{73BAC7D6-516A-44B5-B4B0-C7B08CA8B392}" dt="2026-03-04T05:49:56.527" v="966"/>
           <ac:graphicFrameMkLst>
             <pc:docMk/>
             <pc:sldMk cId="3840876851" sldId="699"/>
@@ -1045,8 +1125,8 @@
           </ac:graphicFrameMkLst>
         </pc:graphicFrameChg>
       </pc:sldChg>
-      <pc:sldChg chg="modSp mod">
-        <pc:chgData name="Gerth Stølting Brodal" userId="04ef4784-6591-4f86-a140-f5c3b108582a" providerId="ADAL" clId="{73BAC7D6-516A-44B5-B4B0-C7B08CA8B392}" dt="2026-03-02T12:09:20.499" v="0" actId="790"/>
+      <pc:sldChg chg="modSp mod modNotes">
+        <pc:chgData name="Gerth Stølting Brodal" userId="04ef4784-6591-4f86-a140-f5c3b108582a" providerId="ADAL" clId="{73BAC7D6-516A-44B5-B4B0-C7B08CA8B392}" dt="2026-03-04T05:49:56.527" v="966"/>
         <pc:sldMkLst>
           <pc:docMk/>
           <pc:sldMk cId="4082157600" sldId="700"/>
@@ -1083,16 +1163,16 @@
             <ac:spMk id="20" creationId="{00000000-0000-0000-0000-000000000000}"/>
           </ac:spMkLst>
         </pc:spChg>
-        <pc:graphicFrameChg chg="modGraphic">
-          <ac:chgData name="Gerth Stølting Brodal" userId="04ef4784-6591-4f86-a140-f5c3b108582a" providerId="ADAL" clId="{73BAC7D6-516A-44B5-B4B0-C7B08CA8B392}" dt="2026-03-02T12:09:20.499" v="0" actId="790"/>
+        <pc:graphicFrameChg chg="mod modGraphic">
+          <ac:chgData name="Gerth Stølting Brodal" userId="04ef4784-6591-4f86-a140-f5c3b108582a" providerId="ADAL" clId="{73BAC7D6-516A-44B5-B4B0-C7B08CA8B392}" dt="2026-03-04T05:42:36.578" v="944"/>
           <ac:graphicFrameMkLst>
             <pc:docMk/>
             <pc:sldMk cId="4082157600" sldId="700"/>
             <ac:graphicFrameMk id="7" creationId="{00000000-0000-0000-0000-000000000000}"/>
           </ac:graphicFrameMkLst>
         </pc:graphicFrameChg>
-        <pc:graphicFrameChg chg="modGraphic">
-          <ac:chgData name="Gerth Stølting Brodal" userId="04ef4784-6591-4f86-a140-f5c3b108582a" providerId="ADAL" clId="{73BAC7D6-516A-44B5-B4B0-C7B08CA8B392}" dt="2026-03-02T12:09:20.499" v="0" actId="790"/>
+        <pc:graphicFrameChg chg="mod modGraphic">
+          <ac:chgData name="Gerth Stølting Brodal" userId="04ef4784-6591-4f86-a140-f5c3b108582a" providerId="ADAL" clId="{73BAC7D6-516A-44B5-B4B0-C7B08CA8B392}" dt="2026-03-04T05:42:47.247" v="948"/>
           <ac:graphicFrameMkLst>
             <pc:docMk/>
             <pc:sldMk cId="4082157600" sldId="700"/>
@@ -1100,8 +1180,8 @@
           </ac:graphicFrameMkLst>
         </pc:graphicFrameChg>
       </pc:sldChg>
-      <pc:sldChg chg="modSp mod">
-        <pc:chgData name="Gerth Stølting Brodal" userId="04ef4784-6591-4f86-a140-f5c3b108582a" providerId="ADAL" clId="{73BAC7D6-516A-44B5-B4B0-C7B08CA8B392}" dt="2026-03-02T12:09:20.499" v="0" actId="790"/>
+      <pc:sldChg chg="modSp mod addAnim delAnim modNotesTx">
+        <pc:chgData name="Gerth Stølting Brodal" userId="04ef4784-6591-4f86-a140-f5c3b108582a" providerId="ADAL" clId="{73BAC7D6-516A-44B5-B4B0-C7B08CA8B392}" dt="2026-03-04T06:17:48.301" v="1177" actId="20577"/>
         <pc:sldMkLst>
           <pc:docMk/>
           <pc:sldMk cId="923762653" sldId="701"/>
@@ -1115,7 +1195,7 @@
           </ac:spMkLst>
         </pc:spChg>
         <pc:spChg chg="mod">
-          <ac:chgData name="Gerth Stølting Brodal" userId="04ef4784-6591-4f86-a140-f5c3b108582a" providerId="ADAL" clId="{73BAC7D6-516A-44B5-B4B0-C7B08CA8B392}" dt="2026-03-02T12:09:20.499" v="0" actId="790"/>
+          <ac:chgData name="Gerth Stølting Brodal" userId="04ef4784-6591-4f86-a140-f5c3b108582a" providerId="ADAL" clId="{73BAC7D6-516A-44B5-B4B0-C7B08CA8B392}" dt="2026-03-04T06:17:18.036" v="1176" actId="21"/>
           <ac:spMkLst>
             <pc:docMk/>
             <pc:sldMk cId="923762653" sldId="701"/>
@@ -1130,6 +1210,14 @@
             <ac:graphicFrameMk id="6" creationId="{4B2DEBA8-48BF-76BA-9C6B-7F6C2D260592}"/>
           </ac:graphicFrameMkLst>
         </pc:graphicFrameChg>
+        <pc:cxnChg chg="mod">
+          <ac:chgData name="Gerth Stølting Brodal" userId="04ef4784-6591-4f86-a140-f5c3b108582a" providerId="ADAL" clId="{73BAC7D6-516A-44B5-B4B0-C7B08CA8B392}" dt="2026-03-04T06:16:52.360" v="1173" actId="14100"/>
+          <ac:cxnSpMkLst>
+            <pc:docMk/>
+            <pc:sldMk cId="923762653" sldId="701"/>
+            <ac:cxnSpMk id="8" creationId="{D2A93F9E-AED5-ACA8-C8B2-7566EE841E45}"/>
+          </ac:cxnSpMkLst>
+        </pc:cxnChg>
       </pc:sldChg>
     </pc:docChg>
   </pc:docChgLst>
@@ -1218,7 +1306,7 @@
           <a:p>
             <a:fld id="{FB1A172F-81D4-4DC4-9113-1DBD56EC3646}" type="datetimeFigureOut">
               <a:rPr lang="en-US" smtClean="0"/>
-              <a:t>3/2/2026</a:t>
+              <a:t>3/4/2026</a:t>
             </a:fld>
             <a:endParaRPr lang="en-US"/>
           </a:p>
@@ -1529,7 +1617,10 @@
           <a:bodyPr/>
           <a:lstStyle/>
           <a:p>
-            <a:endParaRPr lang="en-US" dirty="0"/>
+            <a:r>
+              <a:rPr lang="en-US" dirty="0"/>
+              <a:t>Python specific  - not good programming style</a:t>
+            </a:r>
           </a:p>
         </p:txBody>
       </p:sp>
@@ -2040,7 +2131,7 @@
             </a:r>
             <a:r>
               <a:rPr lang="da-DK" dirty="0"/>
-              <a:t> with the Python version (holds for Python 3.13)</a:t>
+              <a:t> with the Python version (holds for Python 3.14)</a:t>
             </a:r>
             <a:endParaRPr lang="en-US" dirty="0"/>
           </a:p>
@@ -2262,6 +2353,97 @@
     <p:extLst>
       <p:ext uri="{BB962C8B-B14F-4D97-AF65-F5344CB8AC3E}">
         <p14:creationId xmlns:p14="http://schemas.microsoft.com/office/powerpoint/2010/main" val="721478227"/>
+      </p:ext>
+    </p:extLst>
+  </p:cSld>
+  <p:clrMapOvr>
+    <a:masterClrMapping/>
+  </p:clrMapOvr>
+</p:notes>
+</file>
+
+<file path=ppt/notesSlides/notesSlide16.xml><?xml version="1.0" encoding="utf-8"?>
+<p:notes xmlns:a="http://schemas.openxmlformats.org/drawingml/2006/main" xmlns:r="http://schemas.openxmlformats.org/officeDocument/2006/relationships" xmlns:p="http://schemas.openxmlformats.org/presentationml/2006/main">
+  <p:cSld>
+    <p:spTree>
+      <p:nvGrpSpPr>
+        <p:cNvPr id="1" name=""/>
+        <p:cNvGrpSpPr/>
+        <p:nvPr/>
+      </p:nvGrpSpPr>
+      <p:grpSpPr>
+        <a:xfrm>
+          <a:off x="0" y="0"/>
+          <a:ext cx="0" cy="0"/>
+          <a:chOff x="0" y="0"/>
+          <a:chExt cx="0" cy="0"/>
+        </a:xfrm>
+      </p:grpSpPr>
+      <p:sp>
+        <p:nvSpPr>
+          <p:cNvPr id="2" name="Slide Image Placeholder 1"/>
+          <p:cNvSpPr>
+            <a:spLocks noGrp="1" noRot="1" noChangeAspect="1"/>
+          </p:cNvSpPr>
+          <p:nvPr>
+            <p:ph type="sldImg"/>
+          </p:nvPr>
+        </p:nvSpPr>
+        <p:spPr/>
+      </p:sp>
+      <p:sp>
+        <p:nvSpPr>
+          <p:cNvPr id="3" name="Notes Placeholder 2"/>
+          <p:cNvSpPr>
+            <a:spLocks noGrp="1"/>
+          </p:cNvSpPr>
+          <p:nvPr>
+            <p:ph type="body" idx="1"/>
+          </p:nvPr>
+        </p:nvSpPr>
+        <p:spPr/>
+        <p:txBody>
+          <a:bodyPr/>
+          <a:lstStyle/>
+          <a:p>
+            <a:r>
+              <a:rPr lang="en-US" dirty="0"/>
+              <a:t>On float, C++ would report error, Python would not print anything, since </a:t>
+            </a:r>
+            <a:r>
+              <a:rPr lang="en-US"/>
+              <a:t>no “else:”</a:t>
+            </a:r>
+          </a:p>
+        </p:txBody>
+      </p:sp>
+      <p:sp>
+        <p:nvSpPr>
+          <p:cNvPr id="4" name="Slide Number Placeholder 3"/>
+          <p:cNvSpPr>
+            <a:spLocks noGrp="1"/>
+          </p:cNvSpPr>
+          <p:nvPr>
+            <p:ph type="sldNum" sz="quarter" idx="5"/>
+          </p:nvPr>
+        </p:nvSpPr>
+        <p:spPr/>
+        <p:txBody>
+          <a:bodyPr/>
+          <a:lstStyle/>
+          <a:p>
+            <a:fld id="{CD563DD8-32AB-41BE-B1C6-8EAC45222ACE}" type="slidenum">
+              <a:rPr lang="en-US" smtClean="0"/>
+              <a:t>21</a:t>
+            </a:fld>
+            <a:endParaRPr lang="en-US"/>
+          </a:p>
+        </p:txBody>
+      </p:sp>
+    </p:spTree>
+    <p:extLst>
+      <p:ext uri="{BB962C8B-B14F-4D97-AF65-F5344CB8AC3E}">
+        <p14:creationId xmlns:p14="http://schemas.microsoft.com/office/powerpoint/2010/main" val="1232343426"/>
       </p:ext>
     </p:extLst>
   </p:cSld>
@@ -2674,6 +2856,49 @@
             </a:r>
           </a:p>
           <a:p>
+            <a:pPr marL="0" marR="0" lvl="0" indent="0" algn="l" defTabSz="914400" rtl="0" eaLnBrk="1" fontAlgn="auto" latinLnBrk="0" hangingPunct="1">
+              <a:lnSpc>
+                <a:spcPct val="100000"/>
+              </a:lnSpc>
+              <a:spcBef>
+                <a:spcPts val="0"/>
+              </a:spcBef>
+              <a:spcAft>
+                <a:spcPts val="0"/>
+              </a:spcAft>
+              <a:buClrTx/>
+              <a:buSzTx/>
+              <a:buFontTx/>
+              <a:buNone/>
+              <a:tabLst/>
+              <a:defRPr/>
+            </a:pPr>
+            <a:endParaRPr lang="en-US" dirty="0"/>
+          </a:p>
+          <a:p>
+            <a:pPr marL="0" marR="0" lvl="0" indent="0" algn="l" defTabSz="914400" rtl="0" eaLnBrk="1" fontAlgn="auto" latinLnBrk="0" hangingPunct="1">
+              <a:lnSpc>
+                <a:spcPct val="100000"/>
+              </a:lnSpc>
+              <a:spcBef>
+                <a:spcPts val="0"/>
+              </a:spcBef>
+              <a:spcAft>
+                <a:spcPts val="0"/>
+              </a:spcAft>
+              <a:buClrTx/>
+              <a:buSzTx/>
+              <a:buFontTx/>
+              <a:buNone/>
+              <a:tabLst/>
+              <a:defRPr/>
+            </a:pPr>
+            <a:r>
+              <a:rPr lang="en-US" dirty="0"/>
+              <a:t>Forward pointer: If you know what the super class is, you can use either. But if the super class is not yet known you need to use super, which can happen when using multiple inheritance, where the parent class is first defined used the method resolution order (MRO)</a:t>
+            </a:r>
+          </a:p>
+          <a:p>
             <a:endParaRPr lang="en-US" dirty="0"/>
           </a:p>
         </p:txBody>
@@ -2758,7 +2983,18 @@
           <a:bodyPr/>
           <a:lstStyle/>
           <a:p>
-            <a:endParaRPr lang="en-US" dirty="0"/>
+            <a:r>
+              <a:rPr lang="en-US" dirty="0"/>
+              <a:t>Example: </a:t>
+            </a:r>
+            <a:r>
+              <a:rPr lang="en-US" dirty="0" err="1"/>
+              <a:t>DD.set_name</a:t>
+            </a:r>
+            <a:r>
+              <a:rPr lang="en-US" dirty="0"/>
+              <a:t>(’Donald Duck’) first looks int object, then in Student class, then in Person class</a:t>
+            </a:r>
           </a:p>
         </p:txBody>
       </p:sp>
@@ -3279,7 +3515,7 @@
           <a:p>
             <a:fld id="{0560A9CD-0304-4E0B-9E82-E7E0115DE05B}" type="datetimeFigureOut">
               <a:rPr lang="en-US" smtClean="0"/>
-              <a:t>3/2/2026</a:t>
+              <a:t>3/4/2026</a:t>
             </a:fld>
             <a:endParaRPr lang="en-US"/>
           </a:p>
@@ -3447,7 +3683,7 @@
           <a:p>
             <a:fld id="{0560A9CD-0304-4E0B-9E82-E7E0115DE05B}" type="datetimeFigureOut">
               <a:rPr lang="en-US" smtClean="0"/>
-              <a:t>3/2/2026</a:t>
+              <a:t>3/4/2026</a:t>
             </a:fld>
             <a:endParaRPr lang="en-US"/>
           </a:p>
@@ -3625,7 +3861,7 @@
           <a:p>
             <a:fld id="{0560A9CD-0304-4E0B-9E82-E7E0115DE05B}" type="datetimeFigureOut">
               <a:rPr lang="en-US" smtClean="0"/>
-              <a:t>3/2/2026</a:t>
+              <a:t>3/4/2026</a:t>
             </a:fld>
             <a:endParaRPr lang="en-US"/>
           </a:p>
@@ -3808,7 +4044,7 @@
           <a:p>
             <a:fld id="{0560A9CD-0304-4E0B-9E82-E7E0115DE05B}" type="datetimeFigureOut">
               <a:rPr lang="en-US" smtClean="0"/>
-              <a:t>3/2/2026</a:t>
+              <a:t>3/4/2026</a:t>
             </a:fld>
             <a:endParaRPr lang="en-US"/>
           </a:p>
@@ -4053,7 +4289,7 @@
           <a:p>
             <a:fld id="{0560A9CD-0304-4E0B-9E82-E7E0115DE05B}" type="datetimeFigureOut">
               <a:rPr lang="en-US" smtClean="0"/>
-              <a:t>3/2/2026</a:t>
+              <a:t>3/4/2026</a:t>
             </a:fld>
             <a:endParaRPr lang="en-US"/>
           </a:p>
@@ -4282,7 +4518,7 @@
           <a:p>
             <a:fld id="{0560A9CD-0304-4E0B-9E82-E7E0115DE05B}" type="datetimeFigureOut">
               <a:rPr lang="en-US" smtClean="0"/>
-              <a:t>3/2/2026</a:t>
+              <a:t>3/4/2026</a:t>
             </a:fld>
             <a:endParaRPr lang="en-US"/>
           </a:p>
@@ -4646,7 +4882,7 @@
           <a:p>
             <a:fld id="{0560A9CD-0304-4E0B-9E82-E7E0115DE05B}" type="datetimeFigureOut">
               <a:rPr lang="en-US" smtClean="0"/>
-              <a:t>3/2/2026</a:t>
+              <a:t>3/4/2026</a:t>
             </a:fld>
             <a:endParaRPr lang="en-US"/>
           </a:p>
@@ -4763,7 +4999,7 @@
           <a:p>
             <a:fld id="{0560A9CD-0304-4E0B-9E82-E7E0115DE05B}" type="datetimeFigureOut">
               <a:rPr lang="en-US" smtClean="0"/>
-              <a:t>3/2/2026</a:t>
+              <a:t>3/4/2026</a:t>
             </a:fld>
             <a:endParaRPr lang="en-US"/>
           </a:p>
@@ -4858,7 +5094,7 @@
           <a:p>
             <a:fld id="{0560A9CD-0304-4E0B-9E82-E7E0115DE05B}" type="datetimeFigureOut">
               <a:rPr lang="en-US" smtClean="0"/>
-              <a:t>3/2/2026</a:t>
+              <a:t>3/4/2026</a:t>
             </a:fld>
             <a:endParaRPr lang="en-US"/>
           </a:p>
@@ -5133,7 +5369,7 @@
           <a:p>
             <a:fld id="{0560A9CD-0304-4E0B-9E82-E7E0115DE05B}" type="datetimeFigureOut">
               <a:rPr lang="en-US" smtClean="0"/>
-              <a:t>3/2/2026</a:t>
+              <a:t>3/4/2026</a:t>
             </a:fld>
             <a:endParaRPr lang="en-US"/>
           </a:p>
@@ -5385,7 +5621,7 @@
           <a:p>
             <a:fld id="{0560A9CD-0304-4E0B-9E82-E7E0115DE05B}" type="datetimeFigureOut">
               <a:rPr lang="en-US" smtClean="0"/>
-              <a:t>3/2/2026</a:t>
+              <a:t>3/4/2026</a:t>
             </a:fld>
             <a:endParaRPr lang="en-US"/>
           </a:p>
@@ -5596,7 +5832,7 @@
           <a:p>
             <a:fld id="{0560A9CD-0304-4E0B-9E82-E7E0115DE05B}" type="datetimeFigureOut">
               <a:rPr lang="en-US" smtClean="0"/>
-              <a:t>3/2/2026</a:t>
+              <a:t>3/4/2026</a:t>
             </a:fld>
             <a:endParaRPr lang="en-US"/>
           </a:p>
@@ -7703,7 +7939,7 @@
           <p:nvPr>
             <p:extLst>
               <p:ext uri="{D42A27DB-BD31-4B8C-83A1-F6EECF244321}">
-                <p14:modId xmlns:p14="http://schemas.microsoft.com/office/powerpoint/2010/main" val="2344599911"/>
+                <p14:modId xmlns:p14="http://schemas.microsoft.com/office/powerpoint/2010/main" val="738369812"/>
               </p:ext>
             </p:extLst>
           </p:nvPr>
@@ -7814,10 +8050,22 @@
                       </a:pPr>
                       <a:r>
                         <a:rPr lang="en-US" sz="1800" b="1" baseline="0" noProof="0" dirty="0">
-                          <a:latin typeface="Courier New" panose="02070309020205020404" pitchFamily="49" charset="0"/>
-                          <a:cs typeface="Courier New" panose="02070309020205020404" pitchFamily="49" charset="0"/>
-                        </a:rPr>
-                        <a:t>class A:</a:t>
+                          <a:solidFill>
+                            <a:schemeClr val="accent1">
+                              <a:lumMod val="50000"/>
+                            </a:schemeClr>
+                          </a:solidFill>
+                          <a:latin typeface="Courier New" panose="02070309020205020404" pitchFamily="49" charset="0"/>
+                          <a:cs typeface="Courier New" panose="02070309020205020404" pitchFamily="49" charset="0"/>
+                        </a:rPr>
+                        <a:t>class</a:t>
+                      </a:r>
+                      <a:r>
+                        <a:rPr lang="en-US" sz="1800" b="1" baseline="0" noProof="0" dirty="0">
+                          <a:latin typeface="Courier New" panose="02070309020205020404" pitchFamily="49" charset="0"/>
+                          <a:cs typeface="Courier New" panose="02070309020205020404" pitchFamily="49" charset="0"/>
+                        </a:rPr>
+                        <a:t> A:</a:t>
                       </a:r>
                     </a:p>
                     <a:p>
@@ -7834,7 +8082,26 @@
                           <a:latin typeface="Courier New" panose="02070309020205020404" pitchFamily="49" charset="0"/>
                           <a:cs typeface="Courier New" panose="02070309020205020404" pitchFamily="49" charset="0"/>
                         </a:rPr>
-                        <a:t>      def f(self):</a:t>
+                        <a:t>      </a:t>
+                      </a:r>
+                      <a:r>
+                        <a:rPr lang="en-US" sz="1800" b="1" baseline="0" noProof="0" dirty="0">
+                          <a:solidFill>
+                            <a:schemeClr val="accent1">
+                              <a:lumMod val="50000"/>
+                            </a:schemeClr>
+                          </a:solidFill>
+                          <a:latin typeface="Courier New" panose="02070309020205020404" pitchFamily="49" charset="0"/>
+                          <a:cs typeface="Courier New" panose="02070309020205020404" pitchFamily="49" charset="0"/>
+                        </a:rPr>
+                        <a:t>def</a:t>
+                      </a:r>
+                      <a:r>
+                        <a:rPr lang="en-US" sz="1800" b="1" baseline="0" noProof="0" dirty="0">
+                          <a:latin typeface="Courier New" panose="02070309020205020404" pitchFamily="49" charset="0"/>
+                          <a:cs typeface="Courier New" panose="02070309020205020404" pitchFamily="49" charset="0"/>
+                        </a:rPr>
+                        <a:t> f(self):</a:t>
                       </a:r>
                     </a:p>
                     <a:p>
@@ -7851,7 +8118,7 @@
                           <a:latin typeface="Courier New" panose="02070309020205020404" pitchFamily="49" charset="0"/>
                           <a:cs typeface="Courier New" panose="02070309020205020404" pitchFamily="49" charset="0"/>
                         </a:rPr>
-                        <a:t>          print("</a:t>
+                        <a:t>          print('</a:t>
                       </a:r>
                       <a:r>
                         <a:rPr lang="en-US" sz="1800" b="1" baseline="0" noProof="0" dirty="0" err="1">
@@ -7865,7 +8132,7 @@
                           <a:latin typeface="Courier New" panose="02070309020205020404" pitchFamily="49" charset="0"/>
                           <a:cs typeface="Courier New" panose="02070309020205020404" pitchFamily="49" charset="0"/>
                         </a:rPr>
-                        <a:t>")</a:t>
+                        <a:t>')</a:t>
                       </a:r>
                     </a:p>
                     <a:p>
@@ -7913,7 +8180,26 @@
                           <a:latin typeface="Courier New" panose="02070309020205020404" pitchFamily="49" charset="0"/>
                           <a:cs typeface="Courier New" panose="02070309020205020404" pitchFamily="49" charset="0"/>
                         </a:rPr>
-                        <a:t>      def g(self):</a:t>
+                        <a:t>      </a:t>
+                      </a:r>
+                      <a:r>
+                        <a:rPr lang="en-US" sz="1800" b="1" baseline="0" noProof="0" dirty="0">
+                          <a:solidFill>
+                            <a:schemeClr val="accent1">
+                              <a:lumMod val="50000"/>
+                            </a:schemeClr>
+                          </a:solidFill>
+                          <a:latin typeface="Courier New" panose="02070309020205020404" pitchFamily="49" charset="0"/>
+                          <a:cs typeface="Courier New" panose="02070309020205020404" pitchFamily="49" charset="0"/>
+                        </a:rPr>
+                        <a:t>def</a:t>
+                      </a:r>
+                      <a:r>
+                        <a:rPr lang="en-US" sz="1800" b="1" baseline="0" noProof="0" dirty="0">
+                          <a:latin typeface="Courier New" panose="02070309020205020404" pitchFamily="49" charset="0"/>
+                          <a:cs typeface="Courier New" panose="02070309020205020404" pitchFamily="49" charset="0"/>
+                        </a:rPr>
+                        <a:t> g(self):</a:t>
                       </a:r>
                     </a:p>
                     <a:p>
@@ -7933,7 +8219,7 @@
                           <a:latin typeface="Courier New" panose="02070309020205020404" pitchFamily="49" charset="0"/>
                           <a:cs typeface="Courier New" panose="02070309020205020404" pitchFamily="49" charset="0"/>
                         </a:rPr>
-                        <a:t>          print("Ag")</a:t>
+                        <a:t>          print('Ag')</a:t>
                       </a:r>
                     </a:p>
                     <a:p>
@@ -7947,10 +8233,22 @@
                       </a:pPr>
                       <a:r>
                         <a:rPr lang="en-US" sz="1800" b="1" baseline="0" noProof="0" dirty="0">
-                          <a:latin typeface="Courier New" panose="02070309020205020404" pitchFamily="49" charset="0"/>
-                          <a:cs typeface="Courier New" panose="02070309020205020404" pitchFamily="49" charset="0"/>
-                        </a:rPr>
-                        <a:t>class B(A):</a:t>
+                          <a:solidFill>
+                            <a:schemeClr val="accent1">
+                              <a:lumMod val="50000"/>
+                            </a:schemeClr>
+                          </a:solidFill>
+                          <a:latin typeface="Courier New" panose="02070309020205020404" pitchFamily="49" charset="0"/>
+                          <a:cs typeface="Courier New" panose="02070309020205020404" pitchFamily="49" charset="0"/>
+                        </a:rPr>
+                        <a:t>class</a:t>
+                      </a:r>
+                      <a:r>
+                        <a:rPr lang="en-US" sz="1800" b="1" baseline="0" noProof="0" dirty="0">
+                          <a:latin typeface="Courier New" panose="02070309020205020404" pitchFamily="49" charset="0"/>
+                          <a:cs typeface="Courier New" panose="02070309020205020404" pitchFamily="49" charset="0"/>
+                        </a:rPr>
+                        <a:t> B(A):</a:t>
                       </a:r>
                     </a:p>
                     <a:p>
@@ -7967,7 +8265,26 @@
                           <a:latin typeface="Courier New" panose="02070309020205020404" pitchFamily="49" charset="0"/>
                           <a:cs typeface="Courier New" panose="02070309020205020404" pitchFamily="49" charset="0"/>
                         </a:rPr>
-                        <a:t>      def g(self):</a:t>
+                        <a:t>      </a:t>
+                      </a:r>
+                      <a:r>
+                        <a:rPr lang="en-US" sz="1800" b="1" baseline="0" noProof="0" dirty="0">
+                          <a:solidFill>
+                            <a:schemeClr val="accent1">
+                              <a:lumMod val="50000"/>
+                            </a:schemeClr>
+                          </a:solidFill>
+                          <a:latin typeface="Courier New" panose="02070309020205020404" pitchFamily="49" charset="0"/>
+                          <a:cs typeface="Courier New" panose="02070309020205020404" pitchFamily="49" charset="0"/>
+                        </a:rPr>
+                        <a:t>def</a:t>
+                      </a:r>
+                      <a:r>
+                        <a:rPr lang="en-US" sz="1800" b="1" baseline="0" noProof="0" dirty="0">
+                          <a:latin typeface="Courier New" panose="02070309020205020404" pitchFamily="49" charset="0"/>
+                          <a:cs typeface="Courier New" panose="02070309020205020404" pitchFamily="49" charset="0"/>
+                        </a:rPr>
+                        <a:t> g(self):</a:t>
                       </a:r>
                     </a:p>
                     <a:p>
@@ -7987,7 +8304,7 @@
                           <a:latin typeface="Courier New" panose="02070309020205020404" pitchFamily="49" charset="0"/>
                           <a:cs typeface="Courier New" panose="02070309020205020404" pitchFamily="49" charset="0"/>
                         </a:rPr>
-                        <a:t>          print("</a:t>
+                        <a:t>          print('</a:t>
                       </a:r>
                       <a:r>
                         <a:rPr lang="en-US" sz="1800" b="1" baseline="0" noProof="0" dirty="0" err="1">
@@ -8001,7 +8318,7 @@
                           <a:latin typeface="Courier New" panose="02070309020205020404" pitchFamily="49" charset="0"/>
                           <a:cs typeface="Courier New" panose="02070309020205020404" pitchFamily="49" charset="0"/>
                         </a:rPr>
-                        <a:t>")</a:t>
+                        <a:t>')</a:t>
                       </a:r>
                     </a:p>
                     <a:p>
@@ -8295,7 +8612,7 @@
           <p:nvPr>
             <p:extLst>
               <p:ext uri="{D42A27DB-BD31-4B8C-83A1-F6EECF244321}">
-                <p14:modId xmlns:p14="http://schemas.microsoft.com/office/powerpoint/2010/main" val="1298045295"/>
+                <p14:modId xmlns:p14="http://schemas.microsoft.com/office/powerpoint/2010/main" val="1561540582"/>
               </p:ext>
             </p:extLst>
           </p:nvPr>
@@ -8474,7 +8791,7 @@
                           <a:latin typeface="Courier New" panose="02070309020205020404" pitchFamily="49" charset="0"/>
                           <a:cs typeface="Courier New" panose="02070309020205020404" pitchFamily="49" charset="0"/>
                         </a:rPr>
-                        <a:t>          print("</a:t>
+                        <a:t>          print('</a:t>
                       </a:r>
                       <a:r>
                         <a:rPr lang="en-US" sz="1800" b="1" baseline="0" noProof="0" dirty="0" err="1">
@@ -8488,7 +8805,7 @@
                           <a:latin typeface="Courier New" panose="02070309020205020404" pitchFamily="49" charset="0"/>
                           <a:cs typeface="Courier New" panose="02070309020205020404" pitchFamily="49" charset="0"/>
                         </a:rPr>
-                        <a:t>")</a:t>
+                        <a:t>')</a:t>
                       </a:r>
                     </a:p>
                     <a:p>
@@ -8605,7 +8922,7 @@
                           <a:latin typeface="Courier New" panose="02070309020205020404" pitchFamily="49" charset="0"/>
                           <a:cs typeface="Courier New" panose="02070309020205020404" pitchFamily="49" charset="0"/>
                         </a:rPr>
-                        <a:t>          print("</a:t>
+                        <a:t>          print('</a:t>
                       </a:r>
                       <a:r>
                         <a:rPr lang="en-US" sz="1800" b="1" baseline="0" noProof="0" dirty="0">
@@ -8622,7 +8939,7 @@
                           <a:latin typeface="Courier New" panose="02070309020205020404" pitchFamily="49" charset="0"/>
                           <a:cs typeface="Courier New" panose="02070309020205020404" pitchFamily="49" charset="0"/>
                         </a:rPr>
-                        <a:t>")</a:t>
+                        <a:t>')</a:t>
                       </a:r>
                     </a:p>
                     <a:p>
@@ -8724,7 +9041,7 @@
                           <a:latin typeface="Courier New" panose="02070309020205020404" pitchFamily="49" charset="0"/>
                           <a:cs typeface="Courier New" panose="02070309020205020404" pitchFamily="49" charset="0"/>
                         </a:rPr>
-                        <a:t>          print("</a:t>
+                        <a:t>          print('</a:t>
                       </a:r>
                       <a:r>
                         <a:rPr lang="en-US" sz="1800" b="1" baseline="0" noProof="0" dirty="0" err="1">
@@ -8741,7 +9058,7 @@
                           <a:latin typeface="Courier New" panose="02070309020205020404" pitchFamily="49" charset="0"/>
                           <a:cs typeface="Courier New" panose="02070309020205020404" pitchFamily="49" charset="0"/>
                         </a:rPr>
-                        <a:t>")</a:t>
+                        <a:t>')</a:t>
                       </a:r>
                     </a:p>
                     <a:p>
@@ -9008,7 +9325,7 @@
           <p:nvPr>
             <p:extLst>
               <p:ext uri="{D42A27DB-BD31-4B8C-83A1-F6EECF244321}">
-                <p14:modId xmlns:p14="http://schemas.microsoft.com/office/powerpoint/2010/main" val="3833222929"/>
+                <p14:modId xmlns:p14="http://schemas.microsoft.com/office/powerpoint/2010/main" val="1961035541"/>
               </p:ext>
             </p:extLst>
           </p:nvPr>
@@ -9187,7 +9504,7 @@
                           <a:latin typeface="Courier New" panose="02070309020205020404" pitchFamily="49" charset="0"/>
                           <a:cs typeface="Courier New" panose="02070309020205020404" pitchFamily="49" charset="0"/>
                         </a:rPr>
-                        <a:t>          print("</a:t>
+                        <a:t>          print('</a:t>
                       </a:r>
                       <a:r>
                         <a:rPr lang="en-US" sz="1800" b="1" baseline="0" noProof="0" dirty="0" err="1">
@@ -9201,7 +9518,7 @@
                           <a:latin typeface="Courier New" panose="02070309020205020404" pitchFamily="49" charset="0"/>
                           <a:cs typeface="Courier New" panose="02070309020205020404" pitchFamily="49" charset="0"/>
                         </a:rPr>
-                        <a:t>")</a:t>
+                        <a:t>')</a:t>
                       </a:r>
                     </a:p>
                     <a:p>
@@ -9347,7 +9664,7 @@
                           <a:latin typeface="Courier New" panose="02070309020205020404" pitchFamily="49" charset="0"/>
                           <a:cs typeface="Courier New" panose="02070309020205020404" pitchFamily="49" charset="0"/>
                         </a:rPr>
-                        <a:t>          print("</a:t>
+                        <a:t>          print('</a:t>
                       </a:r>
                       <a:r>
                         <a:rPr lang="en-US" sz="1800" b="1" baseline="0" noProof="0" dirty="0" err="1">
@@ -9364,7 +9681,7 @@
                           <a:latin typeface="Courier New" panose="02070309020205020404" pitchFamily="49" charset="0"/>
                           <a:cs typeface="Courier New" panose="02070309020205020404" pitchFamily="49" charset="0"/>
                         </a:rPr>
-                        <a:t>")</a:t>
+                        <a:t>')</a:t>
                       </a:r>
                     </a:p>
                     <a:p>
@@ -10357,7 +10674,7 @@
           <p:nvPr>
             <p:extLst>
               <p:ext uri="{D42A27DB-BD31-4B8C-83A1-F6EECF244321}">
-                <p14:modId xmlns:p14="http://schemas.microsoft.com/office/powerpoint/2010/main" val="1427074304"/>
+                <p14:modId xmlns:p14="http://schemas.microsoft.com/office/powerpoint/2010/main" val="2403946224"/>
               </p:ext>
             </p:extLst>
           </p:nvPr>
@@ -10505,7 +10822,7 @@
                           <a:latin typeface="Courier New" panose="02070309020205020404" pitchFamily="49" charset="0"/>
                           <a:cs typeface="Courier New" panose="02070309020205020404" pitchFamily="49" charset="0"/>
                         </a:rPr>
-                        <a:t>          print("</a:t>
+                        <a:t>          print('</a:t>
                       </a:r>
                       <a:r>
                         <a:rPr lang="en-US" sz="1800" b="1" baseline="0" noProof="0" dirty="0" err="1">
@@ -10519,7 +10836,7 @@
                           <a:latin typeface="Courier New" panose="02070309020205020404" pitchFamily="49" charset="0"/>
                           <a:cs typeface="Courier New" panose="02070309020205020404" pitchFamily="49" charset="0"/>
                         </a:rPr>
-                        <a:t>")</a:t>
+                        <a:t>')</a:t>
                       </a:r>
                     </a:p>
                     <a:p>
@@ -10611,7 +10928,7 @@
                           <a:latin typeface="Courier New" panose="02070309020205020404" pitchFamily="49" charset="0"/>
                           <a:cs typeface="Courier New" panose="02070309020205020404" pitchFamily="49" charset="0"/>
                         </a:rPr>
-                        <a:t>          print("Ag")</a:t>
+                        <a:t>          print('Ag')</a:t>
                       </a:r>
                     </a:p>
                     <a:p>
@@ -10679,7 +10996,7 @@
                           <a:latin typeface="Courier New" panose="02070309020205020404" pitchFamily="49" charset="0"/>
                           <a:cs typeface="Courier New" panose="02070309020205020404" pitchFamily="49" charset="0"/>
                         </a:rPr>
-                        <a:t>          print("</a:t>
+                        <a:t>          print('</a:t>
                       </a:r>
                       <a:r>
                         <a:rPr lang="en-US" sz="1800" b="1" baseline="0" noProof="0" dirty="0" err="1">
@@ -10693,7 +11010,7 @@
                           <a:latin typeface="Courier New" panose="02070309020205020404" pitchFamily="49" charset="0"/>
                           <a:cs typeface="Courier New" panose="02070309020205020404" pitchFamily="49" charset="0"/>
                         </a:rPr>
-                        <a:t>")</a:t>
+                        <a:t>')</a:t>
                       </a:r>
                     </a:p>
                     <a:p>
@@ -11117,7 +11434,7 @@
           <p:nvPr>
             <p:extLst>
               <p:ext uri="{D42A27DB-BD31-4B8C-83A1-F6EECF244321}">
-                <p14:modId xmlns:p14="http://schemas.microsoft.com/office/powerpoint/2010/main" val="1199120318"/>
+                <p14:modId xmlns:p14="http://schemas.microsoft.com/office/powerpoint/2010/main" val="3320590651"/>
               </p:ext>
             </p:extLst>
           </p:nvPr>
@@ -11325,7 +11642,7 @@
                           <a:latin typeface="Courier New" panose="02070309020205020404" pitchFamily="49" charset="0"/>
                           <a:cs typeface="Courier New" panose="02070309020205020404" pitchFamily="49" charset="0"/>
                         </a:rPr>
-                        <a:t>        print("Alice says hello")</a:t>
+                        <a:t>        print('Alice says hello')</a:t>
                       </a:r>
                     </a:p>
                     <a:p>
@@ -11395,7 +11712,7 @@
                           <a:latin typeface="Courier New" panose="02070309020205020404" pitchFamily="49" charset="0"/>
                           <a:cs typeface="Courier New" panose="02070309020205020404" pitchFamily="49" charset="0"/>
                         </a:rPr>
-                        <a:t>        print("Alice says good night")</a:t>
+                        <a:t>        print('Alice says good night')</a:t>
                       </a:r>
                     </a:p>
                     <a:p>
@@ -11506,7 +11823,7 @@
                           <a:latin typeface="Courier New" panose="02070309020205020404" pitchFamily="49" charset="0"/>
                           <a:cs typeface="Courier New" panose="02070309020205020404" pitchFamily="49" charset="0"/>
                         </a:rPr>
-                        <a:t>        print("Bob says hello")</a:t>
+                        <a:t>        print('Bob says hello')</a:t>
                       </a:r>
                     </a:p>
                     <a:p>
@@ -11576,7 +11893,7 @@
                           <a:latin typeface="Courier New" panose="02070309020205020404" pitchFamily="49" charset="0"/>
                           <a:cs typeface="Courier New" panose="02070309020205020404" pitchFamily="49" charset="0"/>
                         </a:rPr>
-                        <a:t>        print("Bob says good morning")</a:t>
+                        <a:t>        print('Bob says good morning')</a:t>
                       </a:r>
                     </a:p>
                     <a:p>
@@ -13436,7 +13753,7 @@
         </p:nvSpPr>
         <p:spPr>
           <a:xfrm>
-            <a:off x="201011" y="354614"/>
+            <a:off x="158149" y="142228"/>
             <a:ext cx="11763374" cy="1325563"/>
           </a:xfrm>
         </p:spPr>
@@ -13515,14 +13832,14 @@
           <p:nvPr>
             <p:extLst>
               <p:ext uri="{D42A27DB-BD31-4B8C-83A1-F6EECF244321}">
-                <p14:modId xmlns:p14="http://schemas.microsoft.com/office/powerpoint/2010/main" val="2751313478"/>
+                <p14:modId xmlns:p14="http://schemas.microsoft.com/office/powerpoint/2010/main" val="1972300952"/>
               </p:ext>
             </p:extLst>
           </p:nvPr>
         </p:nvGraphicFramePr>
         <p:xfrm>
-          <a:off x="1413543" y="2121853"/>
-          <a:ext cx="6326505" cy="4023360"/>
+          <a:off x="1284955" y="1573213"/>
+          <a:ext cx="6326505" cy="4572000"/>
         </p:xfrm>
         <a:graphic>
           <a:graphicData uri="http://schemas.openxmlformats.org/drawingml/2006/table">
@@ -13720,8 +14037,18 @@
                           <a:latin typeface="Courier New" panose="02070309020205020404" pitchFamily="49" charset="0"/>
                           <a:cs typeface="Courier New" panose="02070309020205020404" pitchFamily="49" charset="0"/>
                         </a:rPr>
-                        <a:t>        print("Alice says hello")</a:t>
-                      </a:r>
+                        <a:t>        print('Alice says hello’)</a:t>
+                      </a:r>
+                      <a:br>
+                        <a:rPr lang="en-US" sz="1800" b="1" noProof="0" dirty="0">
+                          <a:latin typeface="Courier New" panose="02070309020205020404" pitchFamily="49" charset="0"/>
+                          <a:cs typeface="Courier New" panose="02070309020205020404" pitchFamily="49" charset="0"/>
+                        </a:rPr>
+                      </a:br>
+                      <a:endParaRPr lang="en-US" sz="1800" b="1" noProof="0" dirty="0">
+                        <a:latin typeface="Courier New" panose="02070309020205020404" pitchFamily="49" charset="0"/>
+                        <a:cs typeface="Courier New" panose="02070309020205020404" pitchFamily="49" charset="0"/>
+                      </a:endParaRPr>
                     </a:p>
                     <a:p>
                       <a:r>
@@ -13828,7 +14155,7 @@
                           <a:latin typeface="Courier New" panose="02070309020205020404" pitchFamily="49" charset="0"/>
                           <a:cs typeface="Courier New" panose="02070309020205020404" pitchFamily="49" charset="0"/>
                         </a:rPr>
-                        <a:t>        print("Bob says hello")</a:t>
+                        <a:t>        print('Bob says hello')</a:t>
                       </a:r>
                     </a:p>
                     <a:p>
@@ -13933,8 +14260,18 @@
                           <a:latin typeface="Courier New" panose="02070309020205020404" pitchFamily="49" charset="0"/>
                           <a:cs typeface="Courier New" panose="02070309020205020404" pitchFamily="49" charset="0"/>
                         </a:rPr>
-                        <a:t>        print("Bob says good morning")</a:t>
-                      </a:r>
+                        <a:t>        print('Bob says good morning’)</a:t>
+                      </a:r>
+                      <a:br>
+                        <a:rPr lang="en-US" sz="1800" b="1" noProof="0" dirty="0">
+                          <a:latin typeface="Courier New" panose="02070309020205020404" pitchFamily="49" charset="0"/>
+                          <a:cs typeface="Courier New" panose="02070309020205020404" pitchFamily="49" charset="0"/>
+                        </a:rPr>
+                      </a:br>
+                      <a:endParaRPr lang="en-US" sz="1800" b="1" noProof="0" dirty="0">
+                        <a:latin typeface="Courier New" panose="02070309020205020404" pitchFamily="49" charset="0"/>
+                        <a:cs typeface="Courier New" panose="02070309020205020404" pitchFamily="49" charset="0"/>
+                      </a:endParaRPr>
                     </a:p>
                     <a:p>
                       <a:r>
@@ -14188,11 +14525,234 @@
             <a:pPr algn="r"/>
             <a:r>
               <a:rPr lang="en-US" sz="2400" noProof="0" dirty="0"/>
-              <a:t>…example of code injection using multiple inheritance and where body of new class is empty</a:t>
+              <a:t>…example of “code injection” using multiple inheritance and where body of new class is empty</a:t>
             </a:r>
           </a:p>
         </p:txBody>
       </p:sp>
+      <p:graphicFrame>
+        <p:nvGraphicFramePr>
+          <p:cNvPr id="7" name="Table 6" descr="QuizAnswer">
+            <a:extLst>
+              <a:ext uri="{FF2B5EF4-FFF2-40B4-BE49-F238E27FC236}">
+                <a16:creationId xmlns:a16="http://schemas.microsoft.com/office/drawing/2014/main" id="{A7E9FD67-C47B-0470-704B-29B86941CBB0}"/>
+              </a:ext>
+            </a:extLst>
+          </p:cNvPr>
+          <p:cNvGraphicFramePr>
+            <a:graphicFrameLocks noGrp="1"/>
+          </p:cNvGraphicFramePr>
+          <p:nvPr>
+            <p:extLst>
+              <p:ext uri="{D42A27DB-BD31-4B8C-83A1-F6EECF244321}">
+                <p14:modId xmlns:p14="http://schemas.microsoft.com/office/powerpoint/2010/main" val="3760284018"/>
+              </p:ext>
+            </p:extLst>
+          </p:nvPr>
+        </p:nvGraphicFramePr>
+        <p:xfrm>
+          <a:off x="8127280" y="5139373"/>
+          <a:ext cx="3453130" cy="1005840"/>
+        </p:xfrm>
+        <a:graphic>
+          <a:graphicData uri="http://schemas.openxmlformats.org/drawingml/2006/table">
+            <a:tbl>
+              <a:tblPr firstRow="1" bandRow="1">
+                <a:tableStyleId>{5C22544A-7EE6-4342-B048-85BDC9FD1C3A}</a:tableStyleId>
+              </a:tblPr>
+              <a:tblGrid>
+                <a:gridCol w="3453130">
+                  <a:extLst>
+                    <a:ext uri="{9D8B030D-6E8A-4147-A177-3AD203B41FA5}">
+                      <a16:colId xmlns:a16="http://schemas.microsoft.com/office/drawing/2014/main" val="1873682825"/>
+                    </a:ext>
+                  </a:extLst>
+                </a:gridCol>
+              </a:tblGrid>
+              <a:tr h="242643">
+                <a:tc>
+                  <a:txBody>
+                    <a:bodyPr/>
+                    <a:lstStyle/>
+                    <a:p>
+                      <a:r>
+                        <a:rPr lang="en-US" sz="1800" b="1" noProof="0" dirty="0">
+                          <a:latin typeface="Courier New" panose="02070309020205020404" pitchFamily="49" charset="0"/>
+                          <a:cs typeface="Courier New" panose="02070309020205020404" pitchFamily="49" charset="0"/>
+                        </a:rPr>
+                        <a:t>Python shell</a:t>
+                      </a:r>
+                    </a:p>
+                  </a:txBody>
+                  <a:tcPr anchor="ctr">
+                    <a:lnL w="6350" cap="flat" cmpd="sng" algn="ctr">
+                      <a:solidFill>
+                        <a:schemeClr val="tx1"/>
+                      </a:solidFill>
+                      <a:prstDash val="solid"/>
+                      <a:round/>
+                      <a:headEnd type="none" w="med" len="med"/>
+                      <a:tailEnd type="none" w="med" len="med"/>
+                    </a:lnL>
+                    <a:lnR w="6350" cap="flat" cmpd="sng" algn="ctr">
+                      <a:solidFill>
+                        <a:schemeClr val="tx1"/>
+                      </a:solidFill>
+                      <a:prstDash val="solid"/>
+                      <a:round/>
+                      <a:headEnd type="none" w="med" len="med"/>
+                      <a:tailEnd type="none" w="med" len="med"/>
+                    </a:lnR>
+                    <a:lnT w="6350" cap="flat" cmpd="sng" algn="ctr">
+                      <a:solidFill>
+                        <a:schemeClr val="tx1"/>
+                      </a:solidFill>
+                      <a:prstDash val="solid"/>
+                      <a:round/>
+                      <a:headEnd type="none" w="med" len="med"/>
+                      <a:tailEnd type="none" w="med" len="med"/>
+                    </a:lnT>
+                    <a:lnB w="6350" cap="flat" cmpd="sng" algn="ctr">
+                      <a:solidFill>
+                        <a:schemeClr val="tx1"/>
+                      </a:solidFill>
+                      <a:prstDash val="solid"/>
+                      <a:round/>
+                      <a:headEnd type="none" w="med" len="med"/>
+                      <a:tailEnd type="none" w="med" len="med"/>
+                    </a:lnB>
+                    <a:lnTlToBr w="12700" cmpd="sng">
+                      <a:noFill/>
+                      <a:prstDash val="solid"/>
+                    </a:lnTlToBr>
+                    <a:lnBlToTr w="12700" cmpd="sng">
+                      <a:noFill/>
+                      <a:prstDash val="solid"/>
+                    </a:lnBlToTr>
+                    <a:solidFill>
+                      <a:srgbClr val="C00000"/>
+                    </a:solidFill>
+                  </a:tcPr>
+                </a:tc>
+                <a:extLst>
+                  <a:ext uri="{0D108BD9-81ED-4DB2-BD59-A6C34878D82A}">
+                    <a16:rowId xmlns:a16="http://schemas.microsoft.com/office/drawing/2014/main" val="3330819881"/>
+                  </a:ext>
+                </a:extLst>
+              </a:tr>
+              <a:tr h="604202">
+                <a:tc>
+                  <a:txBody>
+                    <a:bodyPr/>
+                    <a:lstStyle/>
+                    <a:p>
+                      <a:pPr marL="266700" indent="-266700">
+                        <a:buClr>
+                          <a:schemeClr val="accent1">
+                            <a:lumMod val="50000"/>
+                          </a:schemeClr>
+                        </a:buClr>
+                        <a:buSzPct val="120000"/>
+                        <a:buFont typeface="Courier New" panose="02070309020205020404" pitchFamily="49" charset="0"/>
+                        <a:buChar char="|"/>
+                      </a:pPr>
+                      <a:r>
+                        <a:rPr lang="en-US" sz="1800" b="1" baseline="0" noProof="0" dirty="0">
+                          <a:solidFill>
+                            <a:schemeClr val="tx1"/>
+                          </a:solidFill>
+                          <a:latin typeface="Courier New" panose="02070309020205020404" pitchFamily="49" charset="0"/>
+                          <a:cs typeface="Courier New" panose="02070309020205020404" pitchFamily="49" charset="0"/>
+                        </a:rPr>
+                        <a:t>Alice says hello</a:t>
+                      </a:r>
+                    </a:p>
+                    <a:p>
+                      <a:pPr marL="266700" indent="-266700">
+                        <a:buClr>
+                          <a:schemeClr val="accent1">
+                            <a:lumMod val="50000"/>
+                          </a:schemeClr>
+                        </a:buClr>
+                        <a:buSzPct val="120000"/>
+                        <a:buFont typeface="Courier New" panose="02070309020205020404" pitchFamily="49" charset="0"/>
+                        <a:buChar char="|"/>
+                      </a:pPr>
+                      <a:r>
+                        <a:rPr lang="en-US" sz="1800" b="1" baseline="0" noProof="0" dirty="0">
+                          <a:solidFill>
+                            <a:schemeClr val="tx1"/>
+                          </a:solidFill>
+                          <a:latin typeface="Courier New" panose="02070309020205020404" pitchFamily="49" charset="0"/>
+                          <a:cs typeface="Courier New" panose="02070309020205020404" pitchFamily="49" charset="0"/>
+                        </a:rPr>
+                        <a:t>Bob says good morning</a:t>
+                      </a:r>
+                    </a:p>
+                  </a:txBody>
+                  <a:tcPr>
+                    <a:lnL w="6350" cap="flat" cmpd="sng" algn="ctr">
+                      <a:solidFill>
+                        <a:schemeClr val="tx1"/>
+                      </a:solidFill>
+                      <a:prstDash val="solid"/>
+                      <a:round/>
+                      <a:headEnd type="none" w="med" len="med"/>
+                      <a:tailEnd type="none" w="med" len="med"/>
+                    </a:lnL>
+                    <a:lnR w="6350" cap="flat" cmpd="sng" algn="ctr">
+                      <a:solidFill>
+                        <a:schemeClr val="tx1"/>
+                      </a:solidFill>
+                      <a:prstDash val="solid"/>
+                      <a:round/>
+                      <a:headEnd type="none" w="med" len="med"/>
+                      <a:tailEnd type="none" w="med" len="med"/>
+                    </a:lnR>
+                    <a:lnT w="6350" cap="flat" cmpd="sng" algn="ctr">
+                      <a:solidFill>
+                        <a:schemeClr val="tx1"/>
+                      </a:solidFill>
+                      <a:prstDash val="solid"/>
+                      <a:round/>
+                      <a:headEnd type="none" w="med" len="med"/>
+                      <a:tailEnd type="none" w="med" len="med"/>
+                    </a:lnT>
+                    <a:lnB w="6350" cap="flat" cmpd="sng" algn="ctr">
+                      <a:solidFill>
+                        <a:schemeClr val="tx1"/>
+                      </a:solidFill>
+                      <a:prstDash val="solid"/>
+                      <a:round/>
+                      <a:headEnd type="none" w="med" len="med"/>
+                      <a:tailEnd type="none" w="med" len="med"/>
+                    </a:lnB>
+                    <a:lnTlToBr w="12700" cmpd="sng">
+                      <a:noFill/>
+                      <a:prstDash val="solid"/>
+                    </a:lnTlToBr>
+                    <a:lnBlToTr w="12700" cmpd="sng">
+                      <a:noFill/>
+                      <a:prstDash val="solid"/>
+                    </a:lnBlToTr>
+                    <a:solidFill>
+                      <a:schemeClr val="accent5">
+                        <a:lumMod val="20000"/>
+                        <a:lumOff val="80000"/>
+                      </a:schemeClr>
+                    </a:solidFill>
+                  </a:tcPr>
+                </a:tc>
+                <a:extLst>
+                  <a:ext uri="{0D108BD9-81ED-4DB2-BD59-A6C34878D82A}">
+                    <a16:rowId xmlns:a16="http://schemas.microsoft.com/office/drawing/2014/main" val="4112970457"/>
+                  </a:ext>
+                </a:extLst>
+              </a:tr>
+            </a:tbl>
+          </a:graphicData>
+        </a:graphic>
+      </p:graphicFrame>
     </p:spTree>
     <p:extLst>
       <p:ext uri="{BB962C8B-B14F-4D97-AF65-F5344CB8AC3E}">
@@ -14277,7 +14837,7 @@
                             </p:stCondLst>
                             <p:childTnLst>
                               <p:par>
-                                <p:cTn id="10" presetID="10" presetClass="entr" presetSubtype="0" fill="hold" grpId="0" nodeType="clickEffect">
+                                <p:cTn id="10" presetID="10" presetClass="entr" presetSubtype="0" fill="hold" nodeType="clickEffect">
                                   <p:stCondLst>
                                     <p:cond delay="0"/>
                                   </p:stCondLst>
@@ -14285,6 +14845,59 @@
                                     <p:set>
                                       <p:cBhvr>
                                         <p:cTn id="11" dur="1" fill="hold">
+                                          <p:stCondLst>
+                                            <p:cond delay="0"/>
+                                          </p:stCondLst>
+                                        </p:cTn>
+                                        <p:tgtEl>
+                                          <p:spTgt spid="7"/>
+                                        </p:tgtEl>
+                                        <p:attrNameLst>
+                                          <p:attrName>style.visibility</p:attrName>
+                                        </p:attrNameLst>
+                                      </p:cBhvr>
+                                      <p:to>
+                                        <p:strVal val="visible"/>
+                                      </p:to>
+                                    </p:set>
+                                    <p:animEffect transition="in" filter="fade">
+                                      <p:cBhvr>
+                                        <p:cTn id="12" dur="500"/>
+                                        <p:tgtEl>
+                                          <p:spTgt spid="7"/>
+                                        </p:tgtEl>
+                                      </p:cBhvr>
+                                    </p:animEffect>
+                                  </p:childTnLst>
+                                </p:cTn>
+                              </p:par>
+                            </p:childTnLst>
+                          </p:cTn>
+                        </p:par>
+                      </p:childTnLst>
+                    </p:cTn>
+                  </p:par>
+                  <p:par>
+                    <p:cTn id="13" fill="hold">
+                      <p:stCondLst>
+                        <p:cond delay="indefinite"/>
+                      </p:stCondLst>
+                      <p:childTnLst>
+                        <p:par>
+                          <p:cTn id="14" fill="hold">
+                            <p:stCondLst>
+                              <p:cond delay="0"/>
+                            </p:stCondLst>
+                            <p:childTnLst>
+                              <p:par>
+                                <p:cTn id="15" presetID="10" presetClass="entr" presetSubtype="0" fill="hold" grpId="0" nodeType="clickEffect">
+                                  <p:stCondLst>
+                                    <p:cond delay="0"/>
+                                  </p:stCondLst>
+                                  <p:childTnLst>
+                                    <p:set>
+                                      <p:cBhvr>
+                                        <p:cTn id="16" dur="1" fill="hold">
                                           <p:stCondLst>
                                             <p:cond delay="0"/>
                                           </p:stCondLst>
@@ -14302,7 +14915,7 @@
                                     </p:set>
                                     <p:animEffect transition="in" filter="fade">
                                       <p:cBhvr>
-                                        <p:cTn id="12" dur="500"/>
+                                        <p:cTn id="17" dur="500"/>
                                         <p:tgtEl>
                                           <p:spTgt spid="6"/>
                                         </p:tgtEl>
@@ -14922,7 +15535,7 @@
                 <a:latin typeface="Courier New" panose="02070309020205020404" pitchFamily="49" charset="0"/>
                 <a:cs typeface="Courier New" panose="02070309020205020404" pitchFamily="49" charset="0"/>
               </a:rPr>
-              <a:t>("</a:t>
+              <a:t>('</a:t>
             </a:r>
             <a:r>
               <a:rPr lang="en-US" noProof="0" dirty="0" err="1">
@@ -14936,11 +15549,22 @@
                 <a:latin typeface="Courier New" panose="02070309020205020404" pitchFamily="49" charset="0"/>
                 <a:cs typeface="Courier New" panose="02070309020205020404" pitchFamily="49" charset="0"/>
               </a:rPr>
-              <a:t>", object)</a:t>
+              <a:t>', object)</a:t>
             </a:r>
             <a:r>
               <a:rPr lang="en-US" noProof="0" dirty="0"/>
-              <a:t> are true, do not use </a:t>
+              <a:t> are </a:t>
+            </a:r>
+            <a:r>
+              <a:rPr lang="en-US" noProof="0" dirty="0">
+                <a:latin typeface="Courier New" panose="02070309020205020404" pitchFamily="49" charset="0"/>
+                <a:cs typeface="Courier New" panose="02070309020205020404" pitchFamily="49" charset="0"/>
+              </a:rPr>
+              <a:t>True</a:t>
+            </a:r>
+            <a:r>
+              <a:rPr lang="en-US" noProof="0" dirty="0"/>
+              <a:t>, do not use </a:t>
             </a:r>
             <a:r>
               <a:rPr lang="en-US" noProof="0" dirty="0">
@@ -15611,7 +16235,7 @@
           <p:nvPr>
             <p:extLst>
               <p:ext uri="{D42A27DB-BD31-4B8C-83A1-F6EECF244321}">
-                <p14:modId xmlns:p14="http://schemas.microsoft.com/office/powerpoint/2010/main" val="1468338952"/>
+                <p14:modId xmlns:p14="http://schemas.microsoft.com/office/powerpoint/2010/main" val="2597984297"/>
               </p:ext>
             </p:extLst>
           </p:nvPr>
@@ -15728,7 +16352,7 @@
                           <a:latin typeface="Courier New" panose="02070309020205020404" pitchFamily="49" charset="0"/>
                           <a:cs typeface="Courier New" panose="02070309020205020404" pitchFamily="49" charset="0"/>
                         </a:rPr>
-                        <a:t>"</a:t>
+                        <a:t>'</a:t>
                       </a:r>
                       <a:r>
                         <a:rPr lang="en-US" sz="1800" b="1" baseline="0" noProof="0" dirty="0" err="1">
@@ -15748,7 +16372,7 @@
                           <a:latin typeface="Courier New" panose="02070309020205020404" pitchFamily="49" charset="0"/>
                           <a:cs typeface="Courier New" panose="02070309020205020404" pitchFamily="49" charset="0"/>
                         </a:rPr>
-                        <a:t>" </a:t>
+                        <a:t>' </a:t>
                       </a:r>
                       <a:r>
                         <a:rPr lang="en-US" sz="1800" b="1" baseline="0" noProof="0" dirty="0">
@@ -15768,7 +16392,7 @@
                           <a:latin typeface="Courier New" panose="02070309020205020404" pitchFamily="49" charset="0"/>
                           <a:cs typeface="Courier New" panose="02070309020205020404" pitchFamily="49" charset="0"/>
                         </a:rPr>
-                        <a:t> "</a:t>
+                        <a:t> '</a:t>
                       </a:r>
                       <a:r>
                         <a:rPr lang="en-US" sz="1800" b="1" baseline="0" noProof="0" dirty="0" err="1">
@@ -15788,7 +16412,7 @@
                           <a:latin typeface="Courier New" panose="02070309020205020404" pitchFamily="49" charset="0"/>
                           <a:cs typeface="Courier New" panose="02070309020205020404" pitchFamily="49" charset="0"/>
                         </a:rPr>
-                        <a:t>"</a:t>
+                        <a:t>'</a:t>
                       </a:r>
                     </a:p>
                     <a:p>
@@ -15830,7 +16454,7 @@
                           <a:latin typeface="Courier New" panose="02070309020205020404" pitchFamily="49" charset="0"/>
                           <a:cs typeface="Courier New" panose="02070309020205020404" pitchFamily="49" charset="0"/>
                         </a:rPr>
-                        <a:t>"</a:t>
+                        <a:t>'</a:t>
                       </a:r>
                       <a:r>
                         <a:rPr lang="en-US" sz="1800" b="1" baseline="0" noProof="0" dirty="0" err="1">
@@ -15850,7 +16474,7 @@
                           <a:latin typeface="Courier New" panose="02070309020205020404" pitchFamily="49" charset="0"/>
                           <a:cs typeface="Courier New" panose="02070309020205020404" pitchFamily="49" charset="0"/>
                         </a:rPr>
-                        <a:t>" </a:t>
+                        <a:t>' </a:t>
                       </a:r>
                       <a:r>
                         <a:rPr lang="en-US" sz="1800" b="1" baseline="0" noProof="0" dirty="0">
@@ -15870,7 +16494,7 @@
                           <a:latin typeface="Courier New" panose="02070309020205020404" pitchFamily="49" charset="0"/>
                           <a:cs typeface="Courier New" panose="02070309020205020404" pitchFamily="49" charset="0"/>
                         </a:rPr>
-                        <a:t> "</a:t>
+                        <a:t> '</a:t>
                       </a:r>
                       <a:r>
                         <a:rPr lang="en-US" sz="1800" b="1" baseline="0" noProof="0" dirty="0" err="1">
@@ -15890,7 +16514,7 @@
                           <a:latin typeface="Courier New" panose="02070309020205020404" pitchFamily="49" charset="0"/>
                           <a:cs typeface="Courier New" panose="02070309020205020404" pitchFamily="49" charset="0"/>
                         </a:rPr>
-                        <a:t>"[1:]</a:t>
+                        <a:t>'[1:]</a:t>
                       </a:r>
                     </a:p>
                     <a:p>
@@ -15932,7 +16556,7 @@
                           <a:latin typeface="Courier New" panose="02070309020205020404" pitchFamily="49" charset="0"/>
                           <a:cs typeface="Courier New" panose="02070309020205020404" pitchFamily="49" charset="0"/>
                         </a:rPr>
-                        <a:t>x, y = "</a:t>
+                        <a:t>x, y = '</a:t>
                       </a:r>
                       <a:r>
                         <a:rPr lang="en-US" sz="1800" b="1" baseline="0" noProof="0" dirty="0" err="1">
@@ -15952,7 +16576,7 @@
                           <a:latin typeface="Courier New" panose="02070309020205020404" pitchFamily="49" charset="0"/>
                           <a:cs typeface="Courier New" panose="02070309020205020404" pitchFamily="49" charset="0"/>
                         </a:rPr>
-                        <a:t>", "</a:t>
+                        <a:t>', '</a:t>
                       </a:r>
                       <a:r>
                         <a:rPr lang="en-US" sz="1800" b="1" baseline="0" noProof="0" dirty="0" err="1">
@@ -15972,7 +16596,7 @@
                           <a:latin typeface="Courier New" panose="02070309020205020404" pitchFamily="49" charset="0"/>
                           <a:cs typeface="Courier New" panose="02070309020205020404" pitchFamily="49" charset="0"/>
                         </a:rPr>
-                        <a:t>"[1:]</a:t>
+                        <a:t>'[1:]</a:t>
                       </a:r>
                     </a:p>
                     <a:p>
@@ -16491,12 +17115,12 @@
         <p:spPr>
           <a:xfrm>
             <a:off x="838200" y="1825625"/>
-            <a:ext cx="10515600" cy="4946650"/>
+            <a:ext cx="10213181" cy="4946650"/>
           </a:xfrm>
         </p:spPr>
         <p:txBody>
           <a:bodyPr>
-            <a:normAutofit lnSpcReduction="10000"/>
+            <a:normAutofit fontScale="92500"/>
           </a:bodyPr>
           <a:lstStyle/>
           <a:p>
@@ -16563,7 +17187,18 @@
             <a:pPr lvl="1"/>
             <a:r>
               <a:rPr lang="en-US" noProof="0" dirty="0"/>
-              <a:t>Java and C++’s type systems allow several methods with same name in a class, where they are distinguished by the type of the arguments, whereas Python allows only one method that can have * and ** arguments</a:t>
+              <a:t>Java and C++’s type systems allow several methods with same name in a class, where they are distinguished by the type of the arguments, whereas Python allows only one method that can have * and ** arguments (use </a:t>
+            </a:r>
+            <a:r>
+              <a:rPr lang="en-US" noProof="0" dirty="0" err="1">
+                <a:latin typeface="Courier New" panose="02070309020205020404" pitchFamily="49" charset="0"/>
+                <a:cs typeface="Courier New" panose="02070309020205020404" pitchFamily="49" charset="0"/>
+              </a:rPr>
+              <a:t>isinstance</a:t>
+            </a:r>
+            <a:r>
+              <a:rPr lang="en-US" noProof="0" dirty="0"/>
+              <a:t>)</a:t>
             </a:r>
           </a:p>
           <a:p>
@@ -16640,8 +17275,8 @@
         </p:nvSpPr>
         <p:spPr>
           <a:xfrm>
-            <a:off x="838200" y="1825624"/>
-            <a:ext cx="5284304" cy="4600227"/>
+            <a:off x="838199" y="1825624"/>
+            <a:ext cx="5550243" cy="4600227"/>
           </a:xfrm>
         </p:spPr>
         <p:txBody>
@@ -16725,7 +17360,7 @@
           <a:p>
             <a:r>
               <a:rPr lang="en-US" noProof="0" dirty="0"/>
-              <a:t>It is possible to call the method in the class directly using </a:t>
+              <a:t>It is possible (but rarely necessary) to call the method in the class directly using </a:t>
             </a:r>
             <a:r>
               <a:rPr lang="en-US" i="1" noProof="0" dirty="0" err="1">
@@ -18298,7 +18933,7 @@
         <p:spPr>
           <a:xfrm flipH="1" flipV="1">
             <a:off x="3119718" y="5195821"/>
-            <a:ext cx="853489" cy="1081903"/>
+            <a:ext cx="745051" cy="928013"/>
           </a:xfrm>
           <a:prstGeom prst="straightConnector1">
             <a:avLst/>
@@ -18339,8 +18974,8 @@
         </p:nvSpPr>
         <p:spPr>
           <a:xfrm>
-            <a:off x="4050048" y="6123834"/>
-            <a:ext cx="8141952" cy="646331"/>
+            <a:off x="3793331" y="6123834"/>
+            <a:ext cx="8398669" cy="646331"/>
           </a:xfrm>
           <a:prstGeom prst="rect">
             <a:avLst/>
@@ -18355,7 +18990,7 @@
           <a:p>
             <a:r>
               <a:rPr lang="en-US" noProof="0" dirty="0"/>
-              <a:t>dynamically add a method to an existing class (and all existing instances),</a:t>
+              <a:t>dynamically add a method to an existing class (and all existing instances and subclasses),</a:t>
             </a:r>
           </a:p>
           <a:p>
@@ -20057,7 +20692,7 @@
           <a:p>
             <a:r>
               <a:rPr lang="en-US" noProof="0" dirty="0"/>
-              <a:t>Classes and Objects</a:t>
+              <a:t>Classes and objects</a:t>
             </a:r>
           </a:p>
         </p:txBody>
@@ -20751,7 +21386,7 @@
           <p:nvPr>
             <p:extLst>
               <p:ext uri="{D42A27DB-BD31-4B8C-83A1-F6EECF244321}">
-                <p14:modId xmlns:p14="http://schemas.microsoft.com/office/powerpoint/2010/main" val="1902104844"/>
+                <p14:modId xmlns:p14="http://schemas.microsoft.com/office/powerpoint/2010/main" val="3184480659"/>
               </p:ext>
             </p:extLst>
           </p:nvPr>
@@ -21028,7 +21663,7 @@
                           <a:latin typeface="Courier New" panose="02070309020205020404" pitchFamily="49" charset="0"/>
                           <a:cs typeface="Courier New" panose="02070309020205020404" pitchFamily="49" charset="0"/>
                         </a:rPr>
-                        <a:t> = {'programming' : 'A' }</a:t>
+                        <a:t> = {'programming' : 'A'}</a:t>
                       </a:r>
                       <a:endParaRPr lang="en-US" sz="1800" b="0" i="0" noProof="0" dirty="0">
                         <a:latin typeface="Courier New" panose="02070309020205020404" pitchFamily="49" charset="0"/>
@@ -22659,7 +23294,7 @@
           <a:p>
             <a:r>
               <a:rPr lang="en-US" noProof="0" dirty="0"/>
-              <a:t>Classes and Objects</a:t>
+              <a:t>Classes and objects</a:t>
             </a:r>
           </a:p>
         </p:txBody>
@@ -30406,7 +31041,12 @@
             <p:ph type="title"/>
           </p:nvPr>
         </p:nvSpPr>
-        <p:spPr/>
+        <p:spPr>
+          <a:xfrm>
+            <a:off x="605240" y="426094"/>
+            <a:ext cx="10515600" cy="1014102"/>
+          </a:xfrm>
+        </p:spPr>
         <p:txBody>
           <a:bodyPr/>
           <a:lstStyle/>
@@ -30427,13 +31067,13 @@
           <p:nvPr>
             <p:extLst>
               <p:ext uri="{D42A27DB-BD31-4B8C-83A1-F6EECF244321}">
-                <p14:modId xmlns:p14="http://schemas.microsoft.com/office/powerpoint/2010/main" val="3836712759"/>
+                <p14:modId xmlns:p14="http://schemas.microsoft.com/office/powerpoint/2010/main" val="996299780"/>
               </p:ext>
             </p:extLst>
           </p:nvPr>
         </p:nvGraphicFramePr>
         <p:xfrm>
-          <a:off x="682086" y="1497005"/>
+          <a:off x="8103783" y="2320299"/>
           <a:ext cx="3596006" cy="1706880"/>
         </p:xfrm>
         <a:graphic>
@@ -30754,13 +31394,13 @@
           <p:nvPr>
             <p:extLst>
               <p:ext uri="{D42A27DB-BD31-4B8C-83A1-F6EECF244321}">
-                <p14:modId xmlns:p14="http://schemas.microsoft.com/office/powerpoint/2010/main" val="401543831"/>
+                <p14:modId xmlns:p14="http://schemas.microsoft.com/office/powerpoint/2010/main" val="2245785510"/>
               </p:ext>
             </p:extLst>
           </p:nvPr>
         </p:nvGraphicFramePr>
         <p:xfrm>
-          <a:off x="6129885" y="4624108"/>
+          <a:off x="492210" y="4801226"/>
           <a:ext cx="5370830" cy="1554480"/>
         </p:xfrm>
         <a:graphic>
@@ -31115,13 +31755,13 @@
           <p:nvPr>
             <p:extLst>
               <p:ext uri="{D42A27DB-BD31-4B8C-83A1-F6EECF244321}">
-                <p14:modId xmlns:p14="http://schemas.microsoft.com/office/powerpoint/2010/main" val="1045235948"/>
+                <p14:modId xmlns:p14="http://schemas.microsoft.com/office/powerpoint/2010/main" val="2713069319"/>
               </p:ext>
             </p:extLst>
           </p:nvPr>
         </p:nvGraphicFramePr>
         <p:xfrm>
-          <a:off x="682086" y="4547908"/>
+          <a:off x="8103785" y="4725026"/>
           <a:ext cx="3596005" cy="1706880"/>
         </p:xfrm>
         <a:graphic>
@@ -31450,13 +32090,15 @@
       <p:cxnSp>
         <p:nvCxnSpPr>
           <p:cNvPr id="14" name="Straight Arrow Connector 13"/>
-          <p:cNvCxnSpPr/>
+          <p:cNvCxnSpPr>
+            <a:cxnSpLocks/>
+          </p:cNvCxnSpPr>
           <p:nvPr/>
         </p:nvCxnSpPr>
         <p:spPr>
-          <a:xfrm flipH="1" flipV="1">
-            <a:off x="4446739" y="5564035"/>
-            <a:ext cx="1514497" cy="0"/>
+          <a:xfrm>
+            <a:off x="6245442" y="5792375"/>
+            <a:ext cx="1564029" cy="0"/>
           </a:xfrm>
           <a:prstGeom prst="straightConnector1">
             <a:avLst/>
@@ -31491,7 +32133,7 @@
         </p:nvSpPr>
         <p:spPr>
           <a:xfrm>
-            <a:off x="4391262" y="4939683"/>
+            <a:off x="6214731" y="5210044"/>
             <a:ext cx="1625449" cy="461665"/>
           </a:xfrm>
           <a:prstGeom prst="rect">
@@ -31524,80 +32166,529 @@
           </a:p>
         </p:txBody>
       </p:sp>
-      <p:cxnSp>
-        <p:nvCxnSpPr>
-          <p:cNvPr id="16" name="Straight Arrow Connector 15"/>
-          <p:cNvCxnSpPr/>
+      <p:grpSp>
+        <p:nvGrpSpPr>
+          <p:cNvPr id="5" name="Group 4">
+            <a:extLst>
+              <a:ext uri="{FF2B5EF4-FFF2-40B4-BE49-F238E27FC236}">
+                <a16:creationId xmlns:a16="http://schemas.microsoft.com/office/drawing/2014/main" id="{B0BED0AA-C56D-CCF2-371A-7324313BBF6B}"/>
+              </a:ext>
+            </a:extLst>
+          </p:cNvPr>
+          <p:cNvGrpSpPr/>
           <p:nvPr/>
-        </p:nvCxnSpPr>
-        <p:spPr>
-          <a:xfrm flipH="1" flipV="1">
-            <a:off x="2527452" y="3380429"/>
-            <a:ext cx="1436" cy="798665"/>
+        </p:nvGrpSpPr>
+        <p:grpSpPr>
+          <a:xfrm>
+            <a:off x="9949151" y="4052273"/>
+            <a:ext cx="1750638" cy="600049"/>
+            <a:chOff x="2527452" y="4184078"/>
+            <a:chExt cx="1750638" cy="600049"/>
           </a:xfrm>
-          <a:prstGeom prst="straightConnector1">
-            <a:avLst/>
-          </a:prstGeom>
-          <a:ln w="76200">
-            <a:solidFill>
-              <a:srgbClr val="C00000"/>
-            </a:solidFill>
-            <a:tailEnd type="triangle"/>
-          </a:ln>
-        </p:spPr>
-        <p:style>
-          <a:lnRef idx="1">
-            <a:schemeClr val="accent1"/>
-          </a:lnRef>
-          <a:fillRef idx="0">
-            <a:schemeClr val="accent1"/>
-          </a:fillRef>
-          <a:effectRef idx="0">
-            <a:schemeClr val="accent1"/>
-          </a:effectRef>
-          <a:fontRef idx="minor">
-            <a:schemeClr val="tx1"/>
-          </a:fontRef>
-        </p:style>
-      </p:cxnSp>
+        </p:grpSpPr>
+        <p:cxnSp>
+          <p:nvCxnSpPr>
+            <p:cNvPr id="16" name="Straight Arrow Connector 15"/>
+            <p:cNvCxnSpPr/>
+            <p:nvPr/>
+          </p:nvCxnSpPr>
+          <p:spPr>
+            <a:xfrm flipH="1" flipV="1">
+              <a:off x="2527452" y="4184078"/>
+              <a:ext cx="1436" cy="600049"/>
+            </a:xfrm>
+            <a:prstGeom prst="straightConnector1">
+              <a:avLst/>
+            </a:prstGeom>
+            <a:ln w="76200">
+              <a:solidFill>
+                <a:srgbClr val="C00000"/>
+              </a:solidFill>
+              <a:tailEnd type="triangle"/>
+            </a:ln>
+          </p:spPr>
+          <p:style>
+            <a:lnRef idx="1">
+              <a:schemeClr val="accent1"/>
+            </a:lnRef>
+            <a:fillRef idx="0">
+              <a:schemeClr val="accent1"/>
+            </a:fillRef>
+            <a:effectRef idx="0">
+              <a:schemeClr val="accent1"/>
+            </a:effectRef>
+            <a:fontRef idx="minor">
+              <a:schemeClr val="tx1"/>
+            </a:fontRef>
+          </p:style>
+        </p:cxnSp>
+        <p:sp>
+          <p:nvSpPr>
+            <p:cNvPr id="18" name="TextBox 17"/>
+            <p:cNvSpPr txBox="1"/>
+            <p:nvPr/>
+          </p:nvSpPr>
+          <p:spPr>
+            <a:xfrm>
+              <a:off x="2584601" y="4299977"/>
+              <a:ext cx="1693489" cy="461665"/>
+            </a:xfrm>
+            <a:prstGeom prst="rect">
+              <a:avLst/>
+            </a:prstGeom>
+            <a:noFill/>
+          </p:spPr>
+          <p:txBody>
+            <a:bodyPr wrap="square" rtlCol="0">
+              <a:spAutoFit/>
+            </a:bodyPr>
+            <a:lstStyle/>
+            <a:p>
+              <a:pPr algn="ctr"/>
+              <a:r>
+                <a:rPr lang="en-US" sz="2400" b="1" noProof="0" dirty="0">
+                  <a:solidFill>
+                    <a:srgbClr val="C00000"/>
+                  </a:solidFill>
+                </a:rPr>
+                <a:t>parent class</a:t>
+              </a:r>
+              <a:endParaRPr lang="en-US" sz="2400" noProof="0" dirty="0">
+                <a:solidFill>
+                  <a:srgbClr val="C00000"/>
+                </a:solidFill>
+                <a:latin typeface="Courier New" panose="02070309020205020404" pitchFamily="49" charset="0"/>
+                <a:cs typeface="Courier New" panose="02070309020205020404" pitchFamily="49" charset="0"/>
+              </a:endParaRPr>
+            </a:p>
+          </p:txBody>
+        </p:sp>
+      </p:grpSp>
+      <p:graphicFrame>
+        <p:nvGraphicFramePr>
+          <p:cNvPr id="3" name="Table 2">
+            <a:extLst>
+              <a:ext uri="{FF2B5EF4-FFF2-40B4-BE49-F238E27FC236}">
+                <a16:creationId xmlns:a16="http://schemas.microsoft.com/office/drawing/2014/main" id="{9A506DDC-96F9-7D50-744A-D7293098E33E}"/>
+              </a:ext>
+            </a:extLst>
+          </p:cNvPr>
+          <p:cNvGraphicFramePr>
+            <a:graphicFrameLocks noGrp="1"/>
+          </p:cNvGraphicFramePr>
+          <p:nvPr>
+            <p:extLst>
+              <p:ext uri="{D42A27DB-BD31-4B8C-83A1-F6EECF244321}">
+                <p14:modId xmlns:p14="http://schemas.microsoft.com/office/powerpoint/2010/main" val="633829366"/>
+              </p:ext>
+            </p:extLst>
+          </p:nvPr>
+        </p:nvGraphicFramePr>
+        <p:xfrm>
+          <a:off x="8103783" y="831164"/>
+          <a:ext cx="3596006" cy="774327"/>
+        </p:xfrm>
+        <a:graphic>
+          <a:graphicData uri="http://schemas.openxmlformats.org/drawingml/2006/table">
+            <a:tbl>
+              <a:tblPr firstRow="1" bandRow="1">
+                <a:tableStyleId>{5C22544A-7EE6-4342-B048-85BDC9FD1C3A}</a:tableStyleId>
+              </a:tblPr>
+              <a:tblGrid>
+                <a:gridCol w="3596006">
+                  <a:extLst>
+                    <a:ext uri="{9D8B030D-6E8A-4147-A177-3AD203B41FA5}">
+                      <a16:colId xmlns:a16="http://schemas.microsoft.com/office/drawing/2014/main" val="1873682825"/>
+                    </a:ext>
+                  </a:extLst>
+                </a:gridCol>
+              </a:tblGrid>
+              <a:tr h="182750">
+                <a:tc>
+                  <a:txBody>
+                    <a:bodyPr/>
+                    <a:lstStyle/>
+                    <a:p>
+                      <a:pPr marL="0" marR="0" lvl="0" indent="0" algn="l" defTabSz="914400" rtl="0" eaLnBrk="1" fontAlgn="auto" latinLnBrk="0" hangingPunct="1">
+                        <a:lnSpc>
+                          <a:spcPct val="100000"/>
+                        </a:lnSpc>
+                        <a:spcBef>
+                          <a:spcPts val="0"/>
+                        </a:spcBef>
+                        <a:spcAft>
+                          <a:spcPts val="0"/>
+                        </a:spcAft>
+                        <a:buClrTx/>
+                        <a:buSzTx/>
+                        <a:buFontTx/>
+                        <a:buNone/>
+                        <a:tabLst/>
+                        <a:defRPr/>
+                      </a:pPr>
+                      <a:r>
+                        <a:rPr lang="en-US" sz="1800" b="0" i="0" noProof="0" dirty="0">
+                          <a:latin typeface="Courier New" panose="02070309020205020404" pitchFamily="49" charset="0"/>
+                          <a:cs typeface="Courier New" panose="02070309020205020404" pitchFamily="49" charset="0"/>
+                        </a:rPr>
+                        <a:t>class object</a:t>
+                      </a:r>
+                      <a:endParaRPr lang="en-US" sz="1800" b="0" i="1" noProof="0" dirty="0">
+                        <a:latin typeface="Courier New" panose="02070309020205020404" pitchFamily="49" charset="0"/>
+                        <a:cs typeface="Courier New" panose="02070309020205020404" pitchFamily="49" charset="0"/>
+                      </a:endParaRPr>
+                    </a:p>
+                  </a:txBody>
+                  <a:tcPr anchor="ctr">
+                    <a:lnL w="6350" cap="flat" cmpd="sng" algn="ctr">
+                      <a:solidFill>
+                        <a:schemeClr val="tx1"/>
+                      </a:solidFill>
+                      <a:prstDash val="solid"/>
+                      <a:round/>
+                      <a:headEnd type="none" w="med" len="med"/>
+                      <a:tailEnd type="none" w="med" len="med"/>
+                    </a:lnL>
+                    <a:lnR w="6350" cap="flat" cmpd="sng" algn="ctr">
+                      <a:solidFill>
+                        <a:schemeClr val="tx1"/>
+                      </a:solidFill>
+                      <a:prstDash val="solid"/>
+                      <a:round/>
+                      <a:headEnd type="none" w="med" len="med"/>
+                      <a:tailEnd type="none" w="med" len="med"/>
+                    </a:lnR>
+                    <a:lnT w="6350" cap="flat" cmpd="sng" algn="ctr">
+                      <a:solidFill>
+                        <a:schemeClr val="tx1"/>
+                      </a:solidFill>
+                      <a:prstDash val="solid"/>
+                      <a:round/>
+                      <a:headEnd type="none" w="med" len="med"/>
+                      <a:tailEnd type="none" w="med" len="med"/>
+                    </a:lnT>
+                    <a:lnB w="6350" cap="flat" cmpd="sng" algn="ctr">
+                      <a:solidFill>
+                        <a:schemeClr val="tx1"/>
+                      </a:solidFill>
+                      <a:prstDash val="solid"/>
+                      <a:round/>
+                      <a:headEnd type="none" w="med" len="med"/>
+                      <a:tailEnd type="none" w="med" len="med"/>
+                    </a:lnB>
+                    <a:lnTlToBr w="12700" cmpd="sng">
+                      <a:noFill/>
+                      <a:prstDash val="solid"/>
+                    </a:lnTlToBr>
+                    <a:lnBlToTr w="12700" cmpd="sng">
+                      <a:noFill/>
+                      <a:prstDash val="solid"/>
+                    </a:lnBlToTr>
+                    <a:solidFill>
+                      <a:schemeClr val="accent1">
+                        <a:lumMod val="50000"/>
+                      </a:schemeClr>
+                    </a:solidFill>
+                  </a:tcPr>
+                </a:tc>
+                <a:extLst>
+                  <a:ext uri="{0D108BD9-81ED-4DB2-BD59-A6C34878D82A}">
+                    <a16:rowId xmlns:a16="http://schemas.microsoft.com/office/drawing/2014/main" val="3330819881"/>
+                  </a:ext>
+                </a:extLst>
+              </a:tr>
+              <a:tr h="408567">
+                <a:tc>
+                  <a:txBody>
+                    <a:bodyPr/>
+                    <a:lstStyle/>
+                    <a:p>
+                      <a:pPr marL="0" marR="0" lvl="0" indent="0" algn="l" defTabSz="914400" rtl="0" eaLnBrk="1" fontAlgn="auto" latinLnBrk="0" hangingPunct="1">
+                        <a:lnSpc>
+                          <a:spcPct val="100000"/>
+                        </a:lnSpc>
+                        <a:spcBef>
+                          <a:spcPts val="0"/>
+                        </a:spcBef>
+                        <a:spcAft>
+                          <a:spcPts val="0"/>
+                        </a:spcAft>
+                        <a:buClr>
+                          <a:schemeClr val="accent1">
+                            <a:lumMod val="50000"/>
+                          </a:schemeClr>
+                        </a:buClr>
+                        <a:buSzTx/>
+                        <a:buFont typeface="Wingdings" panose="05000000000000000000" pitchFamily="2" charset="2"/>
+                        <a:buNone/>
+                        <a:tabLst/>
+                        <a:defRPr/>
+                      </a:pPr>
+                      <a:endParaRPr lang="en-US" sz="1800" i="0" noProof="0" dirty="0">
+                        <a:latin typeface="Courier New" panose="02070309020205020404" pitchFamily="49" charset="0"/>
+                        <a:cs typeface="Courier New" panose="02070309020205020404" pitchFamily="49" charset="0"/>
+                      </a:endParaRPr>
+                    </a:p>
+                  </a:txBody>
+                  <a:tcPr>
+                    <a:lnL w="6350" cap="flat" cmpd="sng" algn="ctr">
+                      <a:solidFill>
+                        <a:schemeClr val="tx1"/>
+                      </a:solidFill>
+                      <a:prstDash val="solid"/>
+                      <a:round/>
+                      <a:headEnd type="none" w="med" len="med"/>
+                      <a:tailEnd type="none" w="med" len="med"/>
+                    </a:lnL>
+                    <a:lnR w="6350" cap="flat" cmpd="sng" algn="ctr">
+                      <a:solidFill>
+                        <a:schemeClr val="tx1"/>
+                      </a:solidFill>
+                      <a:prstDash val="solid"/>
+                      <a:round/>
+                      <a:headEnd type="none" w="med" len="med"/>
+                      <a:tailEnd type="none" w="med" len="med"/>
+                    </a:lnR>
+                    <a:lnT w="6350" cap="flat" cmpd="sng" algn="ctr">
+                      <a:solidFill>
+                        <a:schemeClr val="tx1"/>
+                      </a:solidFill>
+                      <a:prstDash val="solid"/>
+                      <a:round/>
+                      <a:headEnd type="none" w="med" len="med"/>
+                      <a:tailEnd type="none" w="med" len="med"/>
+                    </a:lnT>
+                    <a:lnB w="6350" cap="flat" cmpd="sng" algn="ctr">
+                      <a:solidFill>
+                        <a:schemeClr val="tx1"/>
+                      </a:solidFill>
+                      <a:prstDash val="solid"/>
+                      <a:round/>
+                      <a:headEnd type="none" w="med" len="med"/>
+                      <a:tailEnd type="none" w="med" len="med"/>
+                    </a:lnB>
+                    <a:lnTlToBr w="12700" cmpd="sng">
+                      <a:noFill/>
+                      <a:prstDash val="solid"/>
+                    </a:lnTlToBr>
+                    <a:lnBlToTr w="12700" cmpd="sng">
+                      <a:noFill/>
+                      <a:prstDash val="solid"/>
+                    </a:lnBlToTr>
+                    <a:solidFill>
+                      <a:schemeClr val="accent5">
+                        <a:lumMod val="20000"/>
+                        <a:lumOff val="80000"/>
+                      </a:schemeClr>
+                    </a:solidFill>
+                  </a:tcPr>
+                </a:tc>
+                <a:extLst>
+                  <a:ext uri="{0D108BD9-81ED-4DB2-BD59-A6C34878D82A}">
+                    <a16:rowId xmlns:a16="http://schemas.microsoft.com/office/drawing/2014/main" val="4112970457"/>
+                  </a:ext>
+                </a:extLst>
+              </a:tr>
+            </a:tbl>
+          </a:graphicData>
+        </a:graphic>
+      </p:graphicFrame>
+      <p:grpSp>
+        <p:nvGrpSpPr>
+          <p:cNvPr id="6" name="Group 5">
+            <a:extLst>
+              <a:ext uri="{FF2B5EF4-FFF2-40B4-BE49-F238E27FC236}">
+                <a16:creationId xmlns:a16="http://schemas.microsoft.com/office/drawing/2014/main" id="{7208FCC4-64A7-653E-95CB-130ECB7B2479}"/>
+              </a:ext>
+            </a:extLst>
+          </p:cNvPr>
+          <p:cNvGrpSpPr/>
+          <p:nvPr/>
+        </p:nvGrpSpPr>
+        <p:grpSpPr>
+          <a:xfrm>
+            <a:off x="9949151" y="1647956"/>
+            <a:ext cx="1750638" cy="600049"/>
+            <a:chOff x="2527452" y="4184078"/>
+            <a:chExt cx="1750638" cy="600049"/>
+          </a:xfrm>
+        </p:grpSpPr>
+        <p:cxnSp>
+          <p:nvCxnSpPr>
+            <p:cNvPr id="7" name="Straight Arrow Connector 6">
+              <a:extLst>
+                <a:ext uri="{FF2B5EF4-FFF2-40B4-BE49-F238E27FC236}">
+                  <a16:creationId xmlns:a16="http://schemas.microsoft.com/office/drawing/2014/main" id="{4315005B-87B9-D512-BAA1-38EDCFF65119}"/>
+                </a:ext>
+              </a:extLst>
+            </p:cNvPr>
+            <p:cNvCxnSpPr/>
+            <p:nvPr/>
+          </p:nvCxnSpPr>
+          <p:spPr>
+            <a:xfrm flipH="1" flipV="1">
+              <a:off x="2527452" y="4184078"/>
+              <a:ext cx="1436" cy="600049"/>
+            </a:xfrm>
+            <a:prstGeom prst="straightConnector1">
+              <a:avLst/>
+            </a:prstGeom>
+            <a:ln w="76200">
+              <a:solidFill>
+                <a:srgbClr val="C00000"/>
+              </a:solidFill>
+              <a:tailEnd type="triangle"/>
+            </a:ln>
+          </p:spPr>
+          <p:style>
+            <a:lnRef idx="1">
+              <a:schemeClr val="accent1"/>
+            </a:lnRef>
+            <a:fillRef idx="0">
+              <a:schemeClr val="accent1"/>
+            </a:fillRef>
+            <a:effectRef idx="0">
+              <a:schemeClr val="accent1"/>
+            </a:effectRef>
+            <a:fontRef idx="minor">
+              <a:schemeClr val="tx1"/>
+            </a:fontRef>
+          </p:style>
+        </p:cxnSp>
+        <p:sp>
+          <p:nvSpPr>
+            <p:cNvPr id="8" name="TextBox 7">
+              <a:extLst>
+                <a:ext uri="{FF2B5EF4-FFF2-40B4-BE49-F238E27FC236}">
+                  <a16:creationId xmlns:a16="http://schemas.microsoft.com/office/drawing/2014/main" id="{DA4AFD94-8B08-B55A-419D-D8C75E590CDE}"/>
+                </a:ext>
+              </a:extLst>
+            </p:cNvPr>
+            <p:cNvSpPr txBox="1"/>
+            <p:nvPr/>
+          </p:nvSpPr>
+          <p:spPr>
+            <a:xfrm>
+              <a:off x="2584601" y="4299977"/>
+              <a:ext cx="1693489" cy="461665"/>
+            </a:xfrm>
+            <a:prstGeom prst="rect">
+              <a:avLst/>
+            </a:prstGeom>
+            <a:noFill/>
+          </p:spPr>
+          <p:txBody>
+            <a:bodyPr wrap="square" rtlCol="0">
+              <a:spAutoFit/>
+            </a:bodyPr>
+            <a:lstStyle/>
+            <a:p>
+              <a:pPr algn="ctr"/>
+              <a:r>
+                <a:rPr lang="en-US" sz="2400" b="1" noProof="0" dirty="0">
+                  <a:solidFill>
+                    <a:srgbClr val="C00000"/>
+                  </a:solidFill>
+                </a:rPr>
+                <a:t>parent class</a:t>
+              </a:r>
+              <a:endParaRPr lang="en-US" sz="2400" noProof="0" dirty="0">
+                <a:solidFill>
+                  <a:srgbClr val="C00000"/>
+                </a:solidFill>
+                <a:latin typeface="Courier New" panose="02070309020205020404" pitchFamily="49" charset="0"/>
+                <a:cs typeface="Courier New" panose="02070309020205020404" pitchFamily="49" charset="0"/>
+              </a:endParaRPr>
+            </a:p>
+          </p:txBody>
+        </p:sp>
+      </p:grpSp>
       <p:sp>
         <p:nvSpPr>
-          <p:cNvPr id="18" name="TextBox 17"/>
-          <p:cNvSpPr txBox="1"/>
-          <p:nvPr/>
+          <p:cNvPr id="11" name="Content Placeholder 2">
+            <a:extLst>
+              <a:ext uri="{FF2B5EF4-FFF2-40B4-BE49-F238E27FC236}">
+                <a16:creationId xmlns:a16="http://schemas.microsoft.com/office/drawing/2014/main" id="{804BC34C-4FCC-19E1-6472-038F072B226F}"/>
+              </a:ext>
+            </a:extLst>
+          </p:cNvPr>
+          <p:cNvSpPr>
+            <a:spLocks noGrp="1"/>
+          </p:cNvSpPr>
+          <p:nvPr>
+            <p:ph idx="1"/>
+          </p:nvPr>
         </p:nvSpPr>
         <p:spPr>
           <a:xfrm>
-            <a:off x="2584601" y="3645064"/>
-            <a:ext cx="1693489" cy="461665"/>
+            <a:off x="492210" y="1647956"/>
+            <a:ext cx="6859797" cy="2627091"/>
           </a:xfrm>
-          <a:prstGeom prst="rect">
-            <a:avLst/>
-          </a:prstGeom>
-          <a:noFill/>
         </p:spPr>
         <p:txBody>
-          <a:bodyPr wrap="square" rtlCol="0">
-            <a:spAutoFit/>
+          <a:bodyPr>
+            <a:normAutofit/>
           </a:bodyPr>
           <a:lstStyle/>
           <a:p>
-            <a:pPr algn="ctr"/>
-            <a:r>
-              <a:rPr lang="en-US" sz="2400" b="1" noProof="0" dirty="0">
-                <a:solidFill>
-                  <a:srgbClr val="C00000"/>
-                </a:solidFill>
+            <a:r>
+              <a:rPr lang="en-US" sz="2400" noProof="0" dirty="0"/>
+              <a:t>An attribute lookup searches first </a:t>
+            </a:r>
+            <a:r>
+              <a:rPr lang="en-US" sz="2400" dirty="0"/>
+              <a:t>the attributes of the object, if not found, the lookup </a:t>
+            </a:r>
+            <a:r>
+              <a:rPr lang="en-US" sz="2400" noProof="0" dirty="0"/>
+              <a:t>recursively considers the parent classes</a:t>
+            </a:r>
+          </a:p>
+          <a:p>
+            <a:r>
+              <a:rPr lang="en-US" sz="2400" dirty="0"/>
+              <a:t>All classes have </a:t>
+            </a:r>
+            <a:r>
+              <a:rPr lang="en-US" sz="2400" dirty="0">
+                <a:latin typeface="Courier New" panose="02070309020205020404" pitchFamily="49" charset="0"/>
+                <a:cs typeface="Courier New" panose="02070309020205020404" pitchFamily="49" charset="0"/>
               </a:rPr>
-              <a:t>parent class</a:t>
-            </a:r>
-            <a:endParaRPr lang="en-US" sz="2400" noProof="0" dirty="0">
-              <a:solidFill>
-                <a:srgbClr val="C00000"/>
-              </a:solidFill>
-              <a:latin typeface="Courier New" panose="02070309020205020404" pitchFamily="49" charset="0"/>
-              <a:cs typeface="Courier New" panose="02070309020205020404" pitchFamily="49" charset="0"/>
-            </a:endParaRPr>
+              <a:t>object</a:t>
+            </a:r>
+            <a:r>
+              <a:rPr lang="en-US" sz="2400" dirty="0"/>
+              <a:t> as the ultimate base class (e.g. defining an empty </a:t>
+            </a:r>
+            <a:r>
+              <a:rPr lang="en-US" sz="2400" dirty="0">
+                <a:latin typeface="Courier New" panose="02070309020205020404" pitchFamily="49" charset="0"/>
+                <a:cs typeface="Courier New" panose="02070309020205020404" pitchFamily="49" charset="0"/>
+              </a:rPr>
+              <a:t>__</a:t>
+            </a:r>
+            <a:r>
+              <a:rPr lang="en-US" sz="2400" dirty="0" err="1">
+                <a:latin typeface="Courier New" panose="02070309020205020404" pitchFamily="49" charset="0"/>
+                <a:cs typeface="Courier New" panose="02070309020205020404" pitchFamily="49" charset="0"/>
+              </a:rPr>
+              <a:t>init</a:t>
+            </a:r>
+            <a:r>
+              <a:rPr lang="en-US" sz="2400" dirty="0">
+                <a:latin typeface="Courier New" panose="02070309020205020404" pitchFamily="49" charset="0"/>
+                <a:cs typeface="Courier New" panose="02070309020205020404" pitchFamily="49" charset="0"/>
+              </a:rPr>
+              <a:t>__</a:t>
+            </a:r>
+            <a:r>
+              <a:rPr lang="en-US" sz="2400" dirty="0"/>
+              <a:t> method)</a:t>
+            </a:r>
+            <a:endParaRPr lang="en-US" sz="2400" noProof="0" dirty="0"/>
+          </a:p>
+          <a:p>
+            <a:endParaRPr lang="en-US" sz="2400" noProof="0" dirty="0"/>
           </a:p>
         </p:txBody>
       </p:sp>
@@ -31611,6 +32702,167 @@
   <p:clrMapOvr>
     <a:masterClrMapping/>
   </p:clrMapOvr>
+  <p:timing>
+    <p:tnLst>
+      <p:par>
+        <p:cTn id="1" dur="indefinite" restart="never" nodeType="tmRoot">
+          <p:childTnLst>
+            <p:seq concurrent="1" nextAc="seek">
+              <p:cTn id="2" dur="indefinite" nodeType="mainSeq">
+                <p:childTnLst>
+                  <p:par>
+                    <p:cTn id="3" fill="hold">
+                      <p:stCondLst>
+                        <p:cond delay="indefinite"/>
+                      </p:stCondLst>
+                      <p:childTnLst>
+                        <p:par>
+                          <p:cTn id="4" fill="hold">
+                            <p:stCondLst>
+                              <p:cond delay="0"/>
+                            </p:stCondLst>
+                            <p:childTnLst>
+                              <p:par>
+                                <p:cTn id="5" presetID="10" presetClass="entr" presetSubtype="0" fill="hold" nodeType="clickEffect">
+                                  <p:stCondLst>
+                                    <p:cond delay="0"/>
+                                  </p:stCondLst>
+                                  <p:childTnLst>
+                                    <p:set>
+                                      <p:cBhvr>
+                                        <p:cTn id="6" dur="1" fill="hold">
+                                          <p:stCondLst>
+                                            <p:cond delay="0"/>
+                                          </p:stCondLst>
+                                        </p:cTn>
+                                        <p:tgtEl>
+                                          <p:spTgt spid="3"/>
+                                        </p:tgtEl>
+                                        <p:attrNameLst>
+                                          <p:attrName>style.visibility</p:attrName>
+                                        </p:attrNameLst>
+                                      </p:cBhvr>
+                                      <p:to>
+                                        <p:strVal val="visible"/>
+                                      </p:to>
+                                    </p:set>
+                                    <p:animEffect transition="in" filter="fade">
+                                      <p:cBhvr>
+                                        <p:cTn id="7" dur="500"/>
+                                        <p:tgtEl>
+                                          <p:spTgt spid="3"/>
+                                        </p:tgtEl>
+                                      </p:cBhvr>
+                                    </p:animEffect>
+                                  </p:childTnLst>
+                                </p:cTn>
+                              </p:par>
+                              <p:par>
+                                <p:cTn id="8" presetID="10" presetClass="entr" presetSubtype="0" fill="hold" nodeType="withEffect">
+                                  <p:stCondLst>
+                                    <p:cond delay="0"/>
+                                  </p:stCondLst>
+                                  <p:childTnLst>
+                                    <p:set>
+                                      <p:cBhvr>
+                                        <p:cTn id="9" dur="1" fill="hold">
+                                          <p:stCondLst>
+                                            <p:cond delay="0"/>
+                                          </p:stCondLst>
+                                        </p:cTn>
+                                        <p:tgtEl>
+                                          <p:spTgt spid="6"/>
+                                        </p:tgtEl>
+                                        <p:attrNameLst>
+                                          <p:attrName>style.visibility</p:attrName>
+                                        </p:attrNameLst>
+                                      </p:cBhvr>
+                                      <p:to>
+                                        <p:strVal val="visible"/>
+                                      </p:to>
+                                    </p:set>
+                                    <p:animEffect transition="in" filter="fade">
+                                      <p:cBhvr>
+                                        <p:cTn id="10" dur="500"/>
+                                        <p:tgtEl>
+                                          <p:spTgt spid="6"/>
+                                        </p:tgtEl>
+                                      </p:cBhvr>
+                                    </p:animEffect>
+                                  </p:childTnLst>
+                                </p:cTn>
+                              </p:par>
+                              <p:par>
+                                <p:cTn id="11" presetID="10" presetClass="entr" presetSubtype="0" fill="hold" nodeType="withEffect">
+                                  <p:stCondLst>
+                                    <p:cond delay="0"/>
+                                  </p:stCondLst>
+                                  <p:childTnLst>
+                                    <p:set>
+                                      <p:cBhvr>
+                                        <p:cTn id="12" dur="1" fill="hold">
+                                          <p:stCondLst>
+                                            <p:cond delay="0"/>
+                                          </p:stCondLst>
+                                        </p:cTn>
+                                        <p:tgtEl>
+                                          <p:spTgt spid="11">
+                                            <p:txEl>
+                                              <p:pRg st="1" end="1"/>
+                                            </p:txEl>
+                                          </p:spTgt>
+                                        </p:tgtEl>
+                                        <p:attrNameLst>
+                                          <p:attrName>style.visibility</p:attrName>
+                                        </p:attrNameLst>
+                                      </p:cBhvr>
+                                      <p:to>
+                                        <p:strVal val="visible"/>
+                                      </p:to>
+                                    </p:set>
+                                    <p:animEffect transition="in" filter="fade">
+                                      <p:cBhvr>
+                                        <p:cTn id="13" dur="500"/>
+                                        <p:tgtEl>
+                                          <p:spTgt spid="11">
+                                            <p:txEl>
+                                              <p:pRg st="1" end="1"/>
+                                            </p:txEl>
+                                          </p:spTgt>
+                                        </p:tgtEl>
+                                      </p:cBhvr>
+                                    </p:animEffect>
+                                  </p:childTnLst>
+                                </p:cTn>
+                              </p:par>
+                            </p:childTnLst>
+                          </p:cTn>
+                        </p:par>
+                      </p:childTnLst>
+                    </p:cTn>
+                  </p:par>
+                </p:childTnLst>
+              </p:cTn>
+              <p:prevCondLst>
+                <p:cond evt="onPrev" delay="0">
+                  <p:tgtEl>
+                    <p:sldTgt/>
+                  </p:tgtEl>
+                </p:cond>
+              </p:prevCondLst>
+              <p:nextCondLst>
+                <p:cond evt="onNext" delay="0">
+                  <p:tgtEl>
+                    <p:sldTgt/>
+                  </p:tgtEl>
+                </p:cond>
+              </p:nextCondLst>
+            </p:seq>
+          </p:childTnLst>
+        </p:cTn>
+      </p:par>
+    </p:tnLst>
+  </p:timing>
 </p:sld>
 </file>
 

</xml_diff>

<commit_message>
exercises.html all-slides-with-answers.pdf all-slides.pdf hierarchies.pdf hierarchies.pptx
</commit_message>
<xml_diff>
--- a/ipsa/slides/hierarchies.pptx
+++ b/ipsa/slides/hierarchies.pptx
@@ -148,18 +148,18 @@
   <pc:docChgLst>
     <pc:chgData name="Gerth Stølting Brodal" userId="04ef4784-6591-4f86-a140-f5c3b108582a" providerId="ADAL" clId="{73BAC7D6-516A-44B5-B4B0-C7B08CA8B392}"/>
     <pc:docChg chg="undo custSel modSld">
-      <pc:chgData name="Gerth Stølting Brodal" userId="04ef4784-6591-4f86-a140-f5c3b108582a" providerId="ADAL" clId="{73BAC7D6-516A-44B5-B4B0-C7B08CA8B392}" dt="2026-03-04T06:19:44.158" v="1290" actId="313"/>
+      <pc:chgData name="Gerth Stølting Brodal" userId="04ef4784-6591-4f86-a140-f5c3b108582a" providerId="ADAL" clId="{73BAC7D6-516A-44B5-B4B0-C7B08CA8B392}" dt="2026-03-04T12:17:59.455" v="1301" actId="1037"/>
       <pc:docMkLst>
         <pc:docMk/>
       </pc:docMkLst>
       <pc:sldChg chg="modSp mod">
-        <pc:chgData name="Gerth Stølting Brodal" userId="04ef4784-6591-4f86-a140-f5c3b108582a" providerId="ADAL" clId="{73BAC7D6-516A-44B5-B4B0-C7B08CA8B392}" dt="2026-03-02T12:09:20.499" v="0" actId="790"/>
+        <pc:chgData name="Gerth Stølting Brodal" userId="04ef4784-6591-4f86-a140-f5c3b108582a" providerId="ADAL" clId="{73BAC7D6-516A-44B5-B4B0-C7B08CA8B392}" dt="2026-03-04T12:17:59.455" v="1301" actId="1037"/>
         <pc:sldMkLst>
           <pc:docMk/>
           <pc:sldMk cId="1006511185" sldId="483"/>
         </pc:sldMkLst>
         <pc:spChg chg="mod">
-          <ac:chgData name="Gerth Stølting Brodal" userId="04ef4784-6591-4f86-a140-f5c3b108582a" providerId="ADAL" clId="{73BAC7D6-516A-44B5-B4B0-C7B08CA8B392}" dt="2026-03-02T12:09:20.499" v="0" actId="790"/>
+          <ac:chgData name="Gerth Stølting Brodal" userId="04ef4784-6591-4f86-a140-f5c3b108582a" providerId="ADAL" clId="{73BAC7D6-516A-44B5-B4B0-C7B08CA8B392}" dt="2026-03-04T12:17:54.451" v="1291" actId="20577"/>
           <ac:spMkLst>
             <pc:docMk/>
             <pc:sldMk cId="1006511185" sldId="483"/>
@@ -167,7 +167,7 @@
           </ac:spMkLst>
         </pc:spChg>
         <pc:spChg chg="mod">
-          <ac:chgData name="Gerth Stølting Brodal" userId="04ef4784-6591-4f86-a140-f5c3b108582a" providerId="ADAL" clId="{73BAC7D6-516A-44B5-B4B0-C7B08CA8B392}" dt="2026-03-02T12:09:20.499" v="0" actId="790"/>
+          <ac:chgData name="Gerth Stølting Brodal" userId="04ef4784-6591-4f86-a140-f5c3b108582a" providerId="ADAL" clId="{73BAC7D6-516A-44B5-B4B0-C7B08CA8B392}" dt="2026-03-04T12:17:59.455" v="1301" actId="1037"/>
           <ac:spMkLst>
             <pc:docMk/>
             <pc:sldMk cId="1006511185" sldId="483"/>
@@ -6260,13 +6260,8 @@
             <a:pPr algn="r"/>
             <a:r>
               <a:rPr lang="en-US" noProof="0" dirty="0"/>
-              <a:t>Class </a:t>
-            </a:r>
-            <a:r>
-              <a:rPr lang="en-US" noProof="0" dirty="0" err="1"/>
-              <a:t>hierarcies</a:t>
-            </a:r>
-            <a:endParaRPr lang="en-US" noProof="0" dirty="0"/>
+              <a:t>Class hierarchies</a:t>
+            </a:r>
           </a:p>
         </p:txBody>
       </p:sp>
@@ -6282,7 +6277,7 @@
         </p:nvSpPr>
         <p:spPr>
           <a:xfrm>
-            <a:off x="7936355" y="3920647"/>
+            <a:off x="7788071" y="3920647"/>
             <a:ext cx="3995057" cy="2937353"/>
           </a:xfrm>
         </p:spPr>

</xml_diff>